<commit_message>
docs: fix slide 9 caption overflow and slide 11 tech chip overflow in presentation
</commit_message>
<xml_diff>
--- a/docs/NearKart_Presentation.pptx
+++ b/docs/NearKart_Presentation.pptx
@@ -4,9 +4,6 @@
   <p:sldMasterIdLst>
     <p:sldMasterId id="2147483648" r:id="rId1"/>
   </p:sldMasterIdLst>
-  <p:notesMasterIdLst>
-    <p:notesMasterId r:id="rId14"/>
-  </p:notesMasterIdLst>
   <p:sldIdLst>
     <p:sldId id="256" r:id="rId2"/>
     <p:sldId id="257" r:id="rId3"/>
@@ -21,6 +18,9 @@
     <p:sldId id="266" r:id="rId12"/>
     <p:sldId id="267" r:id="rId13"/>
   </p:sldIdLst>
+  <p:notesMasterIdLst>
+    <p:notesMasterId r:id="rId14"/>
+  </p:notesMasterIdLst>
   <p:sldSz cx="12192000" cy="6858000"/>
   <p:notesSz cx="6858000" cy="12192000"/>
   <p:defaultTextStyle>
@@ -115,20 +115,13 @@
       </a:defRPr>
     </a:lvl9pPr>
   </p:defaultTextStyle>
-  <p:extLst>
-    <p:ext uri="{EFAFB233-063F-42B5-8137-9DF3F51BA10A}">
-      <p15:sldGuideLst xmlns:p15="http://schemas.microsoft.com/office/powerpoint/2012/main"/>
-    </p:ext>
-  </p:extLst>
 </p:presentation>
 </file>
 
 <file path=ppt/charts/chart1.xml><?xml version="1.0" encoding="utf-8"?>
-<c:chartSpace xmlns:c="http://schemas.openxmlformats.org/drawingml/2006/chart" xmlns:a="http://schemas.openxmlformats.org/drawingml/2006/main" xmlns:r="http://schemas.openxmlformats.org/officeDocument/2006/relationships" xmlns:c16r2="http://schemas.microsoft.com/office/drawing/2015/06/chart">
+<c:chartSpace xmlns:c="http://schemas.openxmlformats.org/drawingml/2006/chart" xmlns:a="http://schemas.openxmlformats.org/drawingml/2006/main" xmlns:r="http://schemas.openxmlformats.org/officeDocument/2006/relationships">
   <c:date1904 val="0"/>
-  <c:lang val="en-US"/>
   <c:roundedCorners val="1"/>
-  <c:style val="2"/>
   <c:chart>
     <c:autoTitleDeleted val="1"/>
     <c:plotArea>
@@ -158,25 +151,51 @@
             <a:effectLst/>
           </c:spPr>
           <c:invertIfNegative val="0"/>
+          <c:dLbls>
+            <c:numFmt formatCode="#,##0" sourceLinked="0"/>
+            <c:txPr>
+              <a:bodyPr/>
+              <a:lstStyle/>
+              <a:p>
+                <a:pPr>
+                  <a:defRPr b="1" i="0" strike="noStrike" sz="1300" u="none">
+                    <a:solidFill>
+                      <a:srgbClr val="0A1220"/>
+                    </a:solidFill>
+                    <a:latin typeface="Arial"/>
+                  </a:defRPr>
+                </a:pPr>
+              </a:p>
+            </c:txPr>
+            <c:showLegendKey val="0"/>
+            <c:showVal val="1"/>
+            <c:showCatName val="0"/>
+            <c:showSerName val="0"/>
+            <c:showPercent val="0"/>
+            <c:showBubbleSize val="0"/>
+            <c:showLeaderLines val="0"/>
+          </c:dLbls>
           <c:dPt>
             <c:idx val="0"/>
             <c:invertIfNegative val="0"/>
             <c:bubble3D val="0"/>
-            <c:extLst>
-              <c:ext xmlns:c16="http://schemas.microsoft.com/office/drawing/2014/chart" uri="{C3380CC4-5D6E-409C-BE32-E72D297353CC}">
-                <c16:uniqueId val="{00000001-8C6C-44D0-A256-2A32471C2AA8}"/>
-              </c:ext>
-            </c:extLst>
+            <c:spPr>
+              <a:solidFill>
+                <a:srgbClr val="059669"/>
+              </a:solidFill>
+              <a:effectLst/>
+            </c:spPr>
           </c:dPt>
           <c:dPt>
             <c:idx val="1"/>
             <c:invertIfNegative val="0"/>
             <c:bubble3D val="0"/>
-            <c:extLst>
-              <c:ext xmlns:c16="http://schemas.microsoft.com/office/drawing/2014/chart" uri="{C3380CC4-5D6E-409C-BE32-E72D297353CC}">
-                <c16:uniqueId val="{00000003-8C6C-44D0-A256-2A32471C2AA8}"/>
-              </c:ext>
-            </c:extLst>
+            <c:spPr>
+              <a:solidFill>
+                <a:srgbClr val="059669"/>
+              </a:solidFill>
+              <a:effectLst/>
+            </c:spPr>
           </c:dPt>
           <c:dPt>
             <c:idx val="2"/>
@@ -188,65 +207,25 @@
               </a:solidFill>
               <a:effectLst/>
             </c:spPr>
-            <c:extLst>
-              <c:ext xmlns:c16="http://schemas.microsoft.com/office/drawing/2014/chart" uri="{C3380CC4-5D6E-409C-BE32-E72D297353CC}">
-                <c16:uniqueId val="{00000005-8C6C-44D0-A256-2A32471C2AA8}"/>
-              </c:ext>
-            </c:extLst>
           </c:dPt>
-          <c:dLbls>
-            <c:numFmt formatCode="#,##0" sourceLinked="0"/>
-            <c:spPr>
-              <a:noFill/>
-              <a:ln>
-                <a:noFill/>
-              </a:ln>
-              <a:effectLst/>
-            </c:spPr>
-            <c:txPr>
-              <a:bodyPr/>
-              <a:lstStyle/>
-              <a:p>
-                <a:pPr>
-                  <a:defRPr sz="1300" b="1" i="0" u="none" strike="noStrike">
-                    <a:solidFill>
-                      <a:srgbClr val="0A1220"/>
-                    </a:solidFill>
-                    <a:latin typeface="Arial"/>
-                  </a:defRPr>
-                </a:pPr>
-                <a:endParaRPr lang="en-US"/>
-              </a:p>
-            </c:txPr>
-            <c:showLegendKey val="0"/>
-            <c:showVal val="1"/>
-            <c:showCatName val="0"/>
-            <c:showSerName val="0"/>
-            <c:showPercent val="0"/>
-            <c:showBubbleSize val="0"/>
-            <c:showLeaderLines val="0"/>
-            <c:extLst>
-              <c:ext xmlns:c15="http://schemas.microsoft.com/office/drawing/2012/chart" uri="{CE6537A1-D6FC-4f65-9D91-7224C49458BB}">
-                <c15:showLeaderLines val="0"/>
-              </c:ext>
-            </c:extLst>
-          </c:dLbls>
           <c:cat>
-            <c:strRef>
+            <c:multiLvlStrRef>
               <c:f>Sheet1!$A$2:$A$4</c:f>
-              <c:strCache>
+              <c:multiLvlStrCache>
                 <c:ptCount val="3"/>
-                <c:pt idx="0">
-                  <c:v>2023</c:v>
-                </c:pt>
-                <c:pt idx="1">
-                  <c:v>2026 (est.)</c:v>
-                </c:pt>
-                <c:pt idx="2">
-                  <c:v>2030 (est.)</c:v>
-                </c:pt>
-              </c:strCache>
-            </c:strRef>
+                <c:lvl>
+                  <c:pt idx="0">
+                    <c:v>2023</c:v>
+                  </c:pt>
+                  <c:pt idx="1">
+                    <c:v>2026 (est.)</c:v>
+                  </c:pt>
+                  <c:pt idx="2">
+                    <c:v>2030 (est.)</c:v>
+                  </c:pt>
+                </c:lvl>
+              </c:multiLvlStrCache>
+            </c:multiLvlStrRef>
           </c:cat>
           <c:val>
             <c:numRef>
@@ -266,23 +245,36 @@
               </c:numCache>
             </c:numRef>
           </c:val>
-          <c:extLst>
-            <c:ext xmlns:c16="http://schemas.microsoft.com/office/drawing/2014/chart" uri="{C3380CC4-5D6E-409C-BE32-E72D297353CC}">
-              <c16:uniqueId val="{00000006-8C6C-44D0-A256-2A32471C2AA8}"/>
-            </c:ext>
-          </c:extLst>
         </c:ser>
         <c:dLbls>
+          <c:numFmt formatCode="#,##0" sourceLinked="0"/>
+          <c:txPr>
+            <a:bodyPr/>
+            <a:lstStyle/>
+            <a:p>
+              <a:pPr>
+                <a:defRPr b="1" i="0" strike="noStrike" sz="1300" u="none">
+                  <a:solidFill>
+                    <a:srgbClr val="0A1220"/>
+                  </a:solidFill>
+                  <a:latin typeface="Arial"/>
+                </a:defRPr>
+              </a:pPr>
+            </a:p>
+          </c:txPr>
           <c:showLegendKey val="0"/>
           <c:showVal val="1"/>
           <c:showCatName val="0"/>
           <c:showSerName val="0"/>
           <c:showPercent val="0"/>
           <c:showBubbleSize val="0"/>
+          <c:showLeaderLines val="0"/>
         </c:dLbls>
         <c:gapWidth val="150"/>
+        <c:overlap val="0"/>
         <c:axId val="2094734554"/>
         <c:axId val="2094734552"/>
+        <c:axId val="2094734556"/>
       </c:barChart>
       <c:catAx>
         <c:axId val="2094734554"/>
@@ -323,7 +315,6 @@
         <c:crosses val="autoZero"/>
         <c:auto val="1"/>
         <c:lblAlgn val="ctr"/>
-        <c:lblOffset val="100"/>
         <c:noMultiLvlLbl val="1"/>
       </c:catAx>
       <c:valAx>
@@ -387,7 +378,6 @@
     </c:plotArea>
     <c:plotVisOnly val="1"/>
     <c:dispBlanksAs val="span"/>
-    <c:showDLblsOverMax val="1"/>
   </c:chart>
   <c:spPr>
     <a:solidFill>
@@ -426,10 +416,234 @@
           <a:chExt cx="0" cy="0"/>
         </a:xfrm>
       </p:grpSpPr>
+      <p:sp>
+        <p:nvSpPr>
+          <p:cNvPr id="2" name="Header Placeholder 1"/>
+          <p:cNvSpPr>
+            <a:spLocks noGrp="1"/>
+          </p:cNvSpPr>
+          <p:nvPr>
+            <p:ph type="hdr" sz="quarter"/>
+          </p:nvPr>
+        </p:nvSpPr>
+        <p:spPr>
+          <a:xfrm>
+            <a:off x="0" y="0"/>
+            <a:ext cx="2971800" cy="458788"/>
+          </a:xfrm>
+          <a:prstGeom prst="rect">
+            <a:avLst/>
+          </a:prstGeom>
+        </p:spPr>
+        <p:txBody>
+          <a:bodyPr vert="horz" lIns="91440" tIns="45720" rIns="91440" bIns="45720" rtlCol="0"/>
+          <a:lstStyle>
+            <a:lvl1pPr algn="l">
+              <a:defRPr sz="1200"/>
+            </a:lvl1pPr>
+          </a:lstStyle>
+          <a:p>
+            <a:endParaRPr lang="en-US"/>
+          </a:p>
+        </p:txBody>
+      </p:sp>
+      <p:sp>
+        <p:nvSpPr>
+          <p:cNvPr id="3" name="Date Placeholder 2"/>
+          <p:cNvSpPr>
+            <a:spLocks noGrp="1"/>
+          </p:cNvSpPr>
+          <p:nvPr>
+            <p:ph type="dt" idx="1"/>
+          </p:nvPr>
+        </p:nvSpPr>
+        <p:spPr>
+          <a:xfrm>
+            <a:off x="3884613" y="0"/>
+            <a:ext cx="2971800" cy="458788"/>
+          </a:xfrm>
+          <a:prstGeom prst="rect">
+            <a:avLst/>
+          </a:prstGeom>
+        </p:spPr>
+        <p:txBody>
+          <a:bodyPr vert="horz" lIns="91440" tIns="45720" rIns="91440" bIns="45720" rtlCol="0"/>
+          <a:lstStyle>
+            <a:lvl1pPr algn="r">
+              <a:defRPr sz="1200"/>
+            </a:lvl1pPr>
+          </a:lstStyle>
+          <a:p>
+            <a:fld id="{5282F153-3F37-0F45-9E97-73ACFA13230C}" type="datetimeFigureOut">
+              <a:rPr lang="en-US"/>
+              <a:t>7/23/19</a:t>
+            </a:fld>
+            <a:endParaRPr lang="en-US"/>
+          </a:p>
+        </p:txBody>
+      </p:sp>
+      <p:sp>
+        <p:nvSpPr>
+          <p:cNvPr id="4" name="Slide Image Placeholder 3"/>
+          <p:cNvSpPr>
+            <a:spLocks noGrp="1" noRot="1" noChangeAspect="1"/>
+          </p:cNvSpPr>
+          <p:nvPr>
+            <p:ph type="sldImg" idx="2"/>
+          </p:nvPr>
+        </p:nvSpPr>
+        <p:spPr>
+          <a:xfrm>
+            <a:off x="685800" y="1143000"/>
+            <a:ext cx="5486400" cy="3086100"/>
+          </a:xfrm>
+          <a:prstGeom prst="rect">
+            <a:avLst/>
+          </a:prstGeom>
+          <a:noFill/>
+          <a:ln w="12700">
+            <a:solidFill>
+              <a:prstClr val="black"/>
+            </a:solidFill>
+          </a:ln>
+        </p:spPr>
+        <p:txBody>
+          <a:bodyPr vert="horz" lIns="91440" tIns="45720" rIns="91440" bIns="45720" rtlCol="0" anchor="ctr"/>
+          <a:lstStyle/>
+          <a:p>
+            <a:endParaRPr lang="en-US"/>
+          </a:p>
+        </p:txBody>
+      </p:sp>
+      <p:sp>
+        <p:nvSpPr>
+          <p:cNvPr id="5" name="Notes Placeholder 4"/>
+          <p:cNvSpPr>
+            <a:spLocks noGrp="1"/>
+          </p:cNvSpPr>
+          <p:nvPr>
+            <p:ph type="body" sz="quarter" idx="3"/>
+          </p:nvPr>
+        </p:nvSpPr>
+        <p:spPr>
+          <a:xfrm>
+            <a:off x="685800" y="4400550"/>
+            <a:ext cx="5486400" cy="3600450"/>
+          </a:xfrm>
+          <a:prstGeom prst="rect">
+            <a:avLst/>
+          </a:prstGeom>
+        </p:spPr>
+        <p:txBody>
+          <a:bodyPr vert="horz" lIns="91440" tIns="45720" rIns="91440" bIns="45720" rtlCol="0"/>
+          <a:lstStyle/>
+          <a:p>
+            <a:pPr lvl="0"/>
+            <a:r>
+              <a:rPr lang="en-US"/>
+              <a:t>Click to edit Master text styles</a:t>
+            </a:r>
+          </a:p>
+          <a:p>
+            <a:pPr lvl="1"/>
+            <a:r>
+              <a:rPr lang="en-US"/>
+              <a:t>Second level</a:t>
+            </a:r>
+          </a:p>
+          <a:p>
+            <a:pPr lvl="2"/>
+            <a:r>
+              <a:rPr lang="en-US"/>
+              <a:t>Third level</a:t>
+            </a:r>
+          </a:p>
+          <a:p>
+            <a:pPr lvl="3"/>
+            <a:r>
+              <a:rPr lang="en-US"/>
+              <a:t>Fourth level</a:t>
+            </a:r>
+          </a:p>
+          <a:p>
+            <a:pPr lvl="4"/>
+            <a:r>
+              <a:rPr lang="en-US"/>
+              <a:t>Fifth level</a:t>
+            </a:r>
+          </a:p>
+        </p:txBody>
+      </p:sp>
+      <p:sp>
+        <p:nvSpPr>
+          <p:cNvPr id="6" name="Footer Placeholder 5"/>
+          <p:cNvSpPr>
+            <a:spLocks noGrp="1"/>
+          </p:cNvSpPr>
+          <p:nvPr>
+            <p:ph type="ftr" sz="quarter" idx="4"/>
+          </p:nvPr>
+        </p:nvSpPr>
+        <p:spPr>
+          <a:xfrm>
+            <a:off x="0" y="8685213"/>
+            <a:ext cx="2971800" cy="458787"/>
+          </a:xfrm>
+          <a:prstGeom prst="rect">
+            <a:avLst/>
+          </a:prstGeom>
+        </p:spPr>
+        <p:txBody>
+          <a:bodyPr vert="horz" lIns="91440" tIns="45720" rIns="91440" bIns="45720" rtlCol="0" anchor="b"/>
+          <a:lstStyle>
+            <a:lvl1pPr algn="l">
+              <a:defRPr sz="1200"/>
+            </a:lvl1pPr>
+          </a:lstStyle>
+          <a:p>
+            <a:endParaRPr lang="en-US"/>
+          </a:p>
+        </p:txBody>
+      </p:sp>
+      <p:sp>
+        <p:nvSpPr>
+          <p:cNvPr id="7" name="Slide Number Placeholder 6"/>
+          <p:cNvSpPr>
+            <a:spLocks noGrp="1"/>
+          </p:cNvSpPr>
+          <p:nvPr>
+            <p:ph type="sldNum" sz="quarter" idx="5"/>
+          </p:nvPr>
+        </p:nvSpPr>
+        <p:spPr>
+          <a:xfrm>
+            <a:off x="3884613" y="8685213"/>
+            <a:ext cx="2971800" cy="458787"/>
+          </a:xfrm>
+          <a:prstGeom prst="rect">
+            <a:avLst/>
+          </a:prstGeom>
+        </p:spPr>
+        <p:txBody>
+          <a:bodyPr vert="horz" lIns="91440" tIns="45720" rIns="91440" bIns="45720" rtlCol="0" anchor="b"/>
+          <a:lstStyle>
+            <a:lvl1pPr algn="r">
+              <a:defRPr sz="1200"/>
+            </a:lvl1pPr>
+          </a:lstStyle>
+          <a:p>
+            <a:fld id="{CE5E9CC1-C706-0F49-92D6-E571CC5EEA8F}" type="slidenum">
+              <a:rPr lang="en-US"/>
+              <a:t>‹#›</a:t>
+            </a:fld>
+            <a:endParaRPr lang="en-US"/>
+          </a:p>
+        </p:txBody>
+      </p:sp>
     </p:spTree>
     <p:extLst>
       <p:ext uri="{BB962C8B-B14F-4D97-AF65-F5344CB8AC3E}">
-        <p14:creationId xmlns:p14="http://schemas.microsoft.com/office/powerpoint/2010/main" val="861886529"/>
+        <p14:creationId xmlns:p14="http://schemas.microsoft.com/office/powerpoint/2010/main" val="1024086991"/>
       </p:ext>
     </p:extLst>
   </p:cSld>
@@ -577,6 +791,7 @@
               <a:rPr lang="en-US" dirty="0"/>
               <a:t>SSIP idea presentation. Introduce yourself: Aryan Patel, Computer Engineering, ENO 240753107021, guided by Dr. Anil Suthar (Principal). One line: NearKart delivers from your local kirana in 15-30 minutes - no dark stores.</a:t>
             </a:r>
+            <a:endParaRPr lang="en-US" dirty="0"/>
           </a:p>
         </p:txBody>
       </p:sp>
@@ -664,6 +879,7 @@
               <a:rPr lang="en-US" dirty="0"/>
               <a:t>Market numbers are from RedSeer and public investor disclosures; projections are labelled as estimates. The strategic point: aggregating existing kiranas has near-zero capex per store.</a:t>
             </a:r>
+            <a:endParaRPr lang="en-US" dirty="0"/>
           </a:p>
         </p:txBody>
       </p:sp>
@@ -751,6 +967,7 @@
               <a:rPr lang="en-US" dirty="0"/>
               <a:t>Be explicit about what is simulated in the demo vs what production adds. The pilot is one Ahmedabad locality with 10-20 shops.</a:t>
             </a:r>
+            <a:endParaRPr lang="en-US" dirty="0"/>
           </a:p>
         </p:txBody>
       </p:sp>
@@ -838,6 +1055,7 @@
               <a:rPr lang="en-US" dirty="0"/>
               <a:t>Close with the one-liner: Blinkit speed, kirana soul, zero dark stores. Offer the QR for a live walkthrough.</a:t>
             </a:r>
+            <a:endParaRPr lang="en-US" dirty="0"/>
           </a:p>
         </p:txBody>
       </p:sp>
@@ -925,6 +1143,7 @@
               <a:rPr lang="en-US" dirty="0"/>
               <a:t>Frame the problem around the dark-store model: it wins on speed but displaces local shops, loses money per order, and is opaque for shops and riders.</a:t>
             </a:r>
+            <a:endParaRPr lang="en-US" dirty="0"/>
           </a:p>
         </p:txBody>
       </p:sp>
@@ -1012,6 +1231,7 @@
               <a:rPr lang="en-US" dirty="0"/>
               <a:t>The key architectural idea: not four separate apps, but one live order engine shared by four views. This is what makes the demo feel real.</a:t>
             </a:r>
+            <a:endParaRPr lang="en-US" dirty="0"/>
           </a:p>
         </p:txBody>
       </p:sp>
@@ -1099,6 +1319,7 @@
               <a:rPr lang="en-US" dirty="0"/>
               <a:t>Demo path: add to cart, watch the free-delivery bar, apply coupon NEAR25, checkout COD or demo UPI, then track with OTP.</a:t>
             </a:r>
+            <a:endParaRPr lang="en-US" dirty="0"/>
           </a:p>
         </p:txBody>
       </p:sp>
@@ -1186,6 +1407,7 @@
               <a:rPr lang="en-US" dirty="0"/>
               <a:t>Demo path: accept the incoming order inside 2 minutes, watch stock auto-deduct, mark packed, then show the payout ledger breakdown.</a:t>
             </a:r>
+            <a:endParaRPr lang="en-US" dirty="0"/>
           </a:p>
         </p:txBody>
       </p:sp>
@@ -1273,6 +1495,7 @@
               <a:rPr lang="en-US" dirty="0"/>
               <a:t>Rider: job card shows distance and payout before accepting. Admin: verification queues, disputes with liability matrix, analytics.</a:t>
             </a:r>
+            <a:endParaRPr lang="en-US" dirty="0"/>
           </a:p>
         </p:txBody>
       </p:sp>
@@ -1360,6 +1583,7 @@
               <a:rPr lang="en-US" dirty="0"/>
               <a:t>Hand this QR over during Q&amp;A or a poster. All four role apps are one click away; everything runs on the shared live order engine.</a:t>
             </a:r>
+            <a:endParaRPr lang="en-US" dirty="0"/>
           </a:p>
         </p:txBody>
       </p:sp>
@@ -1447,6 +1671,7 @@
               <a:rPr lang="en-US" dirty="0"/>
               <a:t>These are implemented in src/lib/algorithms.ts and all observable in the demo. This is the moat: local supply orchestrated well.</a:t>
             </a:r>
+            <a:endParaRPr lang="en-US" dirty="0"/>
           </a:p>
         </p:txBody>
       </p:sp>
@@ -1534,6 +1759,7 @@
               <a:rPr lang="en-US" dirty="0"/>
               <a:t>Revenue shown line-by-line in the demo: shop payout ledger has 7% commission and 1% GST TCS. Delivery fee free above 299 drives AOV.</a:t>
             </a:r>
+            <a:endParaRPr lang="en-US" dirty="0"/>
           </a:p>
         </p:txBody>
       </p:sp>
@@ -1606,11 +1832,6 @@
 <file path=ppt/slideMasters/slideMaster1.xml><?xml version="1.0" encoding="utf-8"?>
 <p:sldMaster xmlns:a="http://schemas.openxmlformats.org/drawingml/2006/main" xmlns:r="http://schemas.openxmlformats.org/officeDocument/2006/relationships" xmlns:p="http://schemas.openxmlformats.org/presentationml/2006/main">
   <p:cSld>
-    <p:bg>
-      <p:bgRef idx="1001">
-        <a:schemeClr val="bg1"/>
-      </p:bgRef>
-    </p:bg>
     <p:spTree>
       <p:nvGrpSpPr>
         <p:cNvPr id="1" name=""/>
@@ -1893,7 +2114,6 @@
         <a:solidFill>
           <a:srgbClr val="0B111E"/>
         </a:solidFill>
-        <a:effectLst/>
       </p:bgPr>
     </p:bg>
     <p:spTree>
@@ -1912,14 +2132,14 @@
       </p:grpSpPr>
       <p:pic>
         <p:nvPicPr>
-          <p:cNvPr id="2" name="Image 0" descr="C:/Users/Aryan/Downloads/1image.png"/>
+          <p:cNvPr id="2" name="Image 0" descr="C:/Users/Aryan/Downloads/1image.png">    </p:cNvPr>
           <p:cNvPicPr>
             <a:picLocks noChangeAspect="1"/>
           </p:cNvPicPr>
           <p:nvPr/>
         </p:nvPicPr>
         <p:blipFill>
-          <a:blip r:embed="rId3"/>
+          <a:blip r:embed="rId1"/>
           <a:stretch>
             <a:fillRect/>
           </a:stretch>
@@ -1955,11 +2175,11 @@
           <a:bodyPr wrap="square" lIns="0" tIns="0" rIns="0" bIns="0" rtlCol="0" anchor="ctr"/>
           <a:lstStyle/>
           <a:p>
-            <a:pPr marL="0" indent="0">
-              <a:buNone/>
-            </a:pPr>
-            <a:r>
-              <a:rPr lang="en-US" sz="1200" b="1" kern="0" spc="200" dirty="0">
+            <a:pPr indent="0" marL="0">
+              <a:buNone/>
+            </a:pPr>
+            <a:r>
+              <a:rPr lang="en-US" sz="1200" b="1" spc="200" kern="0" dirty="0">
                 <a:solidFill>
                   <a:srgbClr val="9FB0C0"/>
                 </a:solidFill>
@@ -1994,11 +2214,11 @@
           <a:bodyPr wrap="square" lIns="0" tIns="0" rIns="0" bIns="0" rtlCol="0" anchor="ctr"/>
           <a:lstStyle/>
           <a:p>
-            <a:pPr marL="0" indent="0">
-              <a:buNone/>
-            </a:pPr>
-            <a:r>
-              <a:rPr lang="en-US" sz="1100" kern="0" spc="200" dirty="0">
+            <a:pPr indent="0" marL="0">
+              <a:buNone/>
+            </a:pPr>
+            <a:r>
+              <a:rPr lang="en-US" sz="1100" spc="200" kern="0" dirty="0">
                 <a:solidFill>
                   <a:srgbClr val="6B7C8E"/>
                 </a:solidFill>
@@ -2033,7 +2253,7 @@
           <a:bodyPr wrap="square" lIns="0" tIns="0" rIns="0" bIns="0" rtlCol="0" anchor="ctr"/>
           <a:lstStyle/>
           <a:p>
-            <a:pPr marL="0" indent="0">
+            <a:pPr indent="0" marL="0">
               <a:buNone/>
             </a:pPr>
             <a:r>
@@ -2072,7 +2292,7 @@
           <a:bodyPr wrap="square" lIns="0" tIns="0" rIns="0" bIns="0" rtlCol="0" anchor="ctr"/>
           <a:lstStyle/>
           <a:p>
-            <a:pPr marL="0" indent="0">
+            <a:pPr indent="0" marL="0">
               <a:buNone/>
             </a:pPr>
             <a:r>
@@ -2111,7 +2331,7 @@
           <a:bodyPr wrap="square" lIns="0" tIns="0" rIns="0" bIns="0" rtlCol="0" anchor="ctr"/>
           <a:lstStyle/>
           <a:p>
-            <a:pPr marL="0" indent="0">
+            <a:pPr indent="0" marL="0">
               <a:buNone/>
             </a:pPr>
             <a:r>
@@ -2123,7 +2343,7 @@
                 <a:ea typeface="Segoe UI" pitchFamily="34" charset="-122"/>
                 <a:cs typeface="Segoe UI" pitchFamily="34" charset="-120"/>
               </a:rPr>
-              <a:t>A hyperlocal quick-commerce platform that turns neighbourhood stores into micro-fulfilment centres — 15–30-minute delivery, zero warehouses.</a:t>
+              <a:t>A hyperlocal quick-commerce platform that turns neighbourhood stores into micro-fulfilment centres — 15–30 minute delivery, zero warehouses.</a:t>
             </a:r>
             <a:endParaRPr lang="en-US" sz="1400" dirty="0"/>
           </a:p>
@@ -2150,7 +2370,7 @@
           <a:bodyPr wrap="square" lIns="0" tIns="0" rIns="0" bIns="0" rtlCol="0" anchor="ctr"/>
           <a:lstStyle/>
           <a:p>
-            <a:pPr marL="0" indent="0">
+            <a:pPr indent="0" marL="0">
               <a:spcAft>
                 <a:spcPts val="600"/>
               </a:spcAft>
@@ -2167,21 +2387,7 @@
               </a:rPr>
               <a:t>Aryan Patel</a:t>
             </a:r>
-            <a:r>
-              <a:rPr lang="en-US" sz="1400" dirty="0">
-                <a:solidFill>
-                  <a:srgbClr val="9FB0C0"/>
-                </a:solidFill>
-                <a:latin typeface="Segoe UI" pitchFamily="34" charset="0"/>
-                <a:ea typeface="Segoe UI" pitchFamily="34" charset="-122"/>
-                <a:cs typeface="Segoe UI" pitchFamily="34" charset="-120"/>
-              </a:rPr>
-              <a:t>   Computer Engineering · ENO 240753107021</a:t>
-            </a:r>
-            <a:endParaRPr lang="en-US" sz="1600" dirty="0"/>
-          </a:p>
-          <a:p>
-            <a:pPr marL="0" indent="0">
+            <a:pPr indent="0" marL="0">
               <a:spcAft>
                 <a:spcPts val="600"/>
               </a:spcAft>
@@ -2196,8 +2402,34 @@
                 <a:ea typeface="Segoe UI" pitchFamily="34" charset="-122"/>
                 <a:cs typeface="Segoe UI" pitchFamily="34" charset="-120"/>
               </a:rPr>
+              <a:t>   Computer Engineering · ENO 240753107021</a:t>
+            </a:r>
+            <a:endParaRPr lang="en-US" sz="1600" dirty="0"/>
+          </a:p>
+          <a:p>
+            <a:pPr indent="0" marL="0">
+              <a:spcAft>
+                <a:spcPts val="600"/>
+              </a:spcAft>
+              <a:buNone/>
+            </a:pPr>
+            <a:r>
+              <a:rPr lang="en-US" sz="1400" dirty="0">
+                <a:solidFill>
+                  <a:srgbClr val="9FB0C0"/>
+                </a:solidFill>
+                <a:latin typeface="Segoe UI" pitchFamily="34" charset="0"/>
+                <a:ea typeface="Segoe UI" pitchFamily="34" charset="-122"/>
+                <a:cs typeface="Segoe UI" pitchFamily="34" charset="-120"/>
+              </a:rPr>
               <a:t>Guided by </a:t>
             </a:r>
+            <a:pPr indent="0" marL="0">
+              <a:spcAft>
+                <a:spcPts val="600"/>
+              </a:spcAft>
+              <a:buNone/>
+            </a:pPr>
             <a:r>
               <a:rPr lang="en-US" sz="1400" b="1" dirty="0">
                 <a:solidFill>
@@ -2209,6 +2441,12 @@
               </a:rPr>
               <a:t>Dr. Anil Suthar</a:t>
             </a:r>
+            <a:pPr indent="0" marL="0">
+              <a:spcAft>
+                <a:spcPts val="600"/>
+              </a:spcAft>
+              <a:buNone/>
+            </a:pPr>
             <a:r>
               <a:rPr lang="en-US" sz="1400" dirty="0">
                 <a:solidFill>
@@ -2226,14 +2464,14 @@
       </p:sp>
       <p:pic>
         <p:nvPicPr>
-          <p:cNvPr id="9" name="Image 1" descr="C:/Users/Aryan/Desktop/Nearcart/docs_build/qr.png"/>
+          <p:cNvPr id="9" name="Image 1" descr="C:/Users/Aryan/Desktop/Nearcart/docs_build/qr.png">    </p:cNvPr>
           <p:cNvPicPr>
             <a:picLocks noChangeAspect="1"/>
           </p:cNvPicPr>
           <p:nvPr/>
         </p:nvPicPr>
         <p:blipFill>
-          <a:blip r:embed="rId4"/>
+          <a:blip r:embed="rId2"/>
           <a:stretch>
             <a:fillRect/>
           </a:stretch>
@@ -2269,7 +2507,7 @@
           <a:bodyPr wrap="square" lIns="0" tIns="0" rIns="0" bIns="0" rtlCol="0" anchor="ctr"/>
           <a:lstStyle/>
           <a:p>
-            <a:pPr marL="0" indent="0" algn="ctr">
+            <a:pPr algn="ctr" indent="0" marL="0">
               <a:buNone/>
             </a:pPr>
             <a:r>
@@ -2308,7 +2546,7 @@
           <a:bodyPr wrap="square" lIns="0" tIns="0" rIns="0" bIns="0" rtlCol="0" anchor="ctr"/>
           <a:lstStyle/>
           <a:p>
-            <a:pPr marL="0" indent="0" algn="ctr">
+            <a:pPr algn="ctr" indent="0" marL="0">
               <a:buNone/>
             </a:pPr>
             <a:r>
@@ -2328,14 +2566,14 @@
       </p:sp>
       <p:pic>
         <p:nvPicPr>
-          <p:cNvPr id="12" name="Image 2" descr="C:/Users/Aryan/Downloads/image.png"/>
+          <p:cNvPr id="12" name="Image 2" descr="C:/Users/Aryan/Downloads/image.png">    </p:cNvPr>
           <p:cNvPicPr>
             <a:picLocks noChangeAspect="1"/>
           </p:cNvPicPr>
           <p:nvPr/>
         </p:nvPicPr>
         <p:blipFill>
-          <a:blip r:embed="rId5"/>
+          <a:blip r:embed="rId3"/>
           <a:stretch>
             <a:fillRect/>
           </a:stretch>
@@ -2366,7 +2604,6 @@
         <a:solidFill>
           <a:srgbClr val="F6F8F9"/>
         </a:solidFill>
-        <a:effectLst/>
       </p:bgPr>
     </p:bg>
     <p:spTree>
@@ -2404,11 +2641,11 @@
           <a:bodyPr wrap="square" lIns="0" tIns="0" rIns="0" bIns="0" rtlCol="0" anchor="ctr"/>
           <a:lstStyle/>
           <a:p>
-            <a:pPr marL="0" indent="0">
-              <a:buNone/>
-            </a:pPr>
-            <a:r>
-              <a:rPr lang="en-US" sz="1200" b="1" kern="0" spc="300" dirty="0">
+            <a:pPr indent="0" marL="0">
+              <a:buNone/>
+            </a:pPr>
+            <a:r>
+              <a:rPr lang="en-US" sz="1200" b="1" spc="300" kern="0" dirty="0">
                 <a:solidFill>
                   <a:srgbClr val="059669"/>
                 </a:solidFill>
@@ -2443,7 +2680,7 @@
           <a:bodyPr wrap="square" lIns="0" tIns="0" rIns="0" bIns="0" rtlCol="0" anchor="ctr"/>
           <a:lstStyle/>
           <a:p>
-            <a:pPr marL="0" indent="0">
+            <a:pPr indent="0" marL="0">
               <a:buNone/>
             </a:pPr>
             <a:r>
@@ -2482,7 +2719,7 @@
           <a:bodyPr wrap="square" lIns="0" tIns="0" rIns="0" bIns="0" rtlCol="0" anchor="ctr"/>
           <a:lstStyle/>
           <a:p>
-            <a:pPr marL="0" indent="0">
+            <a:pPr indent="0" marL="0">
               <a:buNone/>
             </a:pPr>
             <a:r>
@@ -2502,7 +2739,7 @@
       </p:sp>
       <p:graphicFrame>
         <p:nvGraphicFramePr>
-          <p:cNvPr id="5" name="Chart 0"/>
+          <p:cNvPr id="5" name="Chart 0" descr=""/>
           <p:cNvGraphicFramePr/>
           <p:nvPr/>
         </p:nvGraphicFramePr>
@@ -2510,9 +2747,9 @@
           <a:off x="548640" y="2194560"/>
           <a:ext cx="6400800" cy="3657600"/>
         </p:xfrm>
-        <a:graphic>
+        <a:graphic xmlns:a="http://schemas.openxmlformats.org/drawingml/2006/main">
           <a:graphicData uri="http://schemas.openxmlformats.org/drawingml/2006/chart">
-            <c:chart xmlns:c="http://schemas.openxmlformats.org/drawingml/2006/chart" xmlns:r="http://schemas.openxmlformats.org/officeDocument/2006/relationships" r:id="rId3"/>
+            <c:chart xmlns:c="http://schemas.openxmlformats.org/drawingml/2006/chart" r:id="rId1"/>
           </a:graphicData>
         </a:graphic>
       </p:graphicFrame>
@@ -2537,7 +2774,7 @@
           <a:bodyPr wrap="square" lIns="0" tIns="0" rIns="0" bIns="0" rtlCol="0" anchor="ctr"/>
           <a:lstStyle/>
           <a:p>
-            <a:pPr marL="0" indent="0">
+            <a:pPr indent="0" marL="0">
               <a:buNone/>
             </a:pPr>
             <a:r>
@@ -2581,7 +2818,7 @@
             <a:prstDash val="solid"/>
           </a:ln>
           <a:effectLst>
-            <a:outerShdw blurRad="114300" dist="38100" dir="2700000" algn="bl" rotWithShape="0">
+            <a:outerShdw sx="100000" sy="100000" kx="0" ky="0" algn="bl" rotWithShape="0" blurRad="114300" dist="38100" dir="2700000">
               <a:srgbClr val="0A1220">
                 <a:alpha val="22000"/>
               </a:srgbClr>
@@ -2610,7 +2847,7 @@
           <a:bodyPr wrap="square" lIns="0" tIns="0" rIns="0" bIns="0" rtlCol="0" anchor="ctr"/>
           <a:lstStyle/>
           <a:p>
-            <a:pPr marL="0" indent="0">
+            <a:pPr indent="0" marL="0">
               <a:spcAft>
                 <a:spcPts val="300"/>
               </a:spcAft>
@@ -2630,7 +2867,7 @@
             <a:endParaRPr lang="en-US" sz="1700" dirty="0"/>
           </a:p>
           <a:p>
-            <a:pPr marL="0" indent="0">
+            <a:pPr indent="0" marL="0">
               <a:spcAft>
                 <a:spcPts val="300"/>
               </a:spcAft>
@@ -2677,7 +2914,7 @@
             <a:prstDash val="solid"/>
           </a:ln>
           <a:effectLst>
-            <a:outerShdw blurRad="114300" dist="38100" dir="2700000" algn="bl" rotWithShape="0">
+            <a:outerShdw sx="100000" sy="100000" kx="0" ky="0" algn="bl" rotWithShape="0" blurRad="114300" dist="38100" dir="2700000">
               <a:srgbClr val="0A1220">
                 <a:alpha val="22000"/>
               </a:srgbClr>
@@ -2706,7 +2943,7 @@
           <a:bodyPr wrap="square" lIns="0" tIns="0" rIns="0" bIns="0" rtlCol="0" anchor="ctr"/>
           <a:lstStyle/>
           <a:p>
-            <a:pPr marL="0" indent="0">
+            <a:pPr indent="0" marL="0">
               <a:spcAft>
                 <a:spcPts val="300"/>
               </a:spcAft>
@@ -2726,7 +2963,7 @@
             <a:endParaRPr lang="en-US" sz="1700" dirty="0"/>
           </a:p>
           <a:p>
-            <a:pPr marL="0" indent="0">
+            <a:pPr indent="0" marL="0">
               <a:spcAft>
                 <a:spcPts val="300"/>
               </a:spcAft>
@@ -2773,7 +3010,7 @@
             <a:prstDash val="solid"/>
           </a:ln>
           <a:effectLst>
-            <a:outerShdw blurRad="114300" dist="38100" dir="2700000" algn="bl" rotWithShape="0">
+            <a:outerShdw sx="100000" sy="100000" kx="0" ky="0" algn="bl" rotWithShape="0" blurRad="114300" dist="38100" dir="2700000">
               <a:srgbClr val="0A1220">
                 <a:alpha val="22000"/>
               </a:srgbClr>
@@ -2802,7 +3039,7 @@
           <a:bodyPr wrap="square" lIns="0" tIns="0" rIns="0" bIns="0" rtlCol="0" anchor="ctr"/>
           <a:lstStyle/>
           <a:p>
-            <a:pPr marL="0" indent="0">
+            <a:pPr indent="0" marL="0">
               <a:spcAft>
                 <a:spcPts val="300"/>
               </a:spcAft>
@@ -2822,7 +3059,7 @@
             <a:endParaRPr lang="en-US" sz="1700" dirty="0"/>
           </a:p>
           <a:p>
-            <a:pPr marL="0" indent="0">
+            <a:pPr indent="0" marL="0">
               <a:spcAft>
                 <a:spcPts val="300"/>
               </a:spcAft>
@@ -2864,7 +3101,7 @@
           <a:bodyPr wrap="square" lIns="0" tIns="0" rIns="0" bIns="0" rtlCol="0" anchor="ctr"/>
           <a:lstStyle/>
           <a:p>
-            <a:pPr marL="0" indent="0" algn="r">
+            <a:pPr algn="r" indent="0" marL="0">
               <a:buNone/>
             </a:pPr>
             <a:r>
@@ -2898,7 +3135,6 @@
         <a:solidFill>
           <a:srgbClr val="F6F8F9"/>
         </a:solidFill>
-        <a:effectLst/>
       </p:bgPr>
     </p:bg>
     <p:spTree>
@@ -2936,11 +3172,11 @@
           <a:bodyPr wrap="square" lIns="0" tIns="0" rIns="0" bIns="0" rtlCol="0" anchor="ctr"/>
           <a:lstStyle/>
           <a:p>
-            <a:pPr marL="0" indent="0">
-              <a:buNone/>
-            </a:pPr>
-            <a:r>
-              <a:rPr lang="en-US" sz="1200" b="1" kern="0" spc="300" dirty="0">
+            <a:pPr indent="0" marL="0">
+              <a:buNone/>
+            </a:pPr>
+            <a:r>
+              <a:rPr lang="en-US" sz="1200" b="1" spc="300" kern="0" dirty="0">
                 <a:solidFill>
                   <a:srgbClr val="059669"/>
                 </a:solidFill>
@@ -2975,7 +3211,7 @@
           <a:bodyPr wrap="square" lIns="0" tIns="0" rIns="0" bIns="0" rtlCol="0" anchor="ctr"/>
           <a:lstStyle/>
           <a:p>
-            <a:pPr marL="0" indent="0">
+            <a:pPr indent="0" marL="0">
               <a:buNone/>
             </a:pPr>
             <a:r>
@@ -3002,7 +3238,7 @@
         <p:spPr>
           <a:xfrm>
             <a:off x="548640" y="1783080"/>
-            <a:ext cx="2592324" cy="475488"/>
+            <a:ext cx="1252728" cy="475488"/>
           </a:xfrm>
           <a:prstGeom prst="roundRect">
             <a:avLst>
@@ -3029,19 +3265,19 @@
         <p:spPr>
           <a:xfrm>
             <a:off x="548640" y="1783080"/>
-            <a:ext cx="2592324" cy="475488"/>
-          </a:xfrm>
-          <a:prstGeom prst="rect">
-            <a:avLst/>
-          </a:prstGeom>
-          <a:noFill/>
-          <a:ln/>
-        </p:spPr>
-        <p:txBody>
-          <a:bodyPr wrap="square" lIns="0" tIns="0" rIns="0" bIns="0" rtlCol="0" anchor="ctr"/>
-          <a:lstStyle/>
-          <a:p>
-            <a:pPr marL="0" indent="0" algn="ctr">
+            <a:ext cx="1252728" cy="475488"/>
+          </a:xfrm>
+          <a:prstGeom prst="rect">
+            <a:avLst/>
+          </a:prstGeom>
+          <a:noFill/>
+          <a:ln/>
+        </p:spPr>
+        <p:txBody>
+          <a:bodyPr wrap="square" lIns="0" tIns="0" rIns="0" bIns="0" rtlCol="0" anchor="ctr"/>
+          <a:lstStyle/>
+          <a:p>
+            <a:pPr algn="ctr" indent="0" marL="0">
               <a:buNone/>
             </a:pPr>
             <a:r>
@@ -3053,7 +3289,7 @@
                 <a:ea typeface="Segoe UI" pitchFamily="34" charset="-122"/>
                 <a:cs typeface="Segoe UI" pitchFamily="34" charset="-120"/>
               </a:rPr>
-              <a:t>Next.js 16 (App Router)</a:t>
+              <a:t>Next.js 16</a:t>
             </a:r>
             <a:endParaRPr lang="en-US" sz="1200" dirty="0"/>
           </a:p>
@@ -3067,8 +3303,8 @@
         </p:nvSpPr>
         <p:spPr>
           <a:xfrm>
-            <a:off x="3342132" y="1783080"/>
-            <a:ext cx="1344168" cy="475488"/>
+            <a:off x="2002536" y="1783080"/>
+            <a:ext cx="1252728" cy="475488"/>
           </a:xfrm>
           <a:prstGeom prst="roundRect">
             <a:avLst>
@@ -3094,20 +3330,20 @@
         </p:nvSpPr>
         <p:spPr>
           <a:xfrm>
-            <a:off x="3342132" y="1783080"/>
-            <a:ext cx="1344168" cy="475488"/>
-          </a:xfrm>
-          <a:prstGeom prst="rect">
-            <a:avLst/>
-          </a:prstGeom>
-          <a:noFill/>
-          <a:ln/>
-        </p:spPr>
-        <p:txBody>
-          <a:bodyPr wrap="square" lIns="0" tIns="0" rIns="0" bIns="0" rtlCol="0" anchor="ctr"/>
-          <a:lstStyle/>
-          <a:p>
-            <a:pPr marL="0" indent="0" algn="ctr">
+            <a:off x="2002536" y="1783080"/>
+            <a:ext cx="1252728" cy="475488"/>
+          </a:xfrm>
+          <a:prstGeom prst="rect">
+            <a:avLst/>
+          </a:prstGeom>
+          <a:noFill/>
+          <a:ln/>
+        </p:spPr>
+        <p:txBody>
+          <a:bodyPr wrap="square" lIns="0" tIns="0" rIns="0" bIns="0" rtlCol="0" anchor="ctr"/>
+          <a:lstStyle/>
+          <a:p>
+            <a:pPr algn="ctr" indent="0" marL="0">
               <a:buNone/>
             </a:pPr>
             <a:r>
@@ -3133,8 +3369,8 @@
         </p:nvSpPr>
         <p:spPr>
           <a:xfrm>
-            <a:off x="4887468" y="1783080"/>
-            <a:ext cx="1824228" cy="475488"/>
+            <a:off x="3456432" y="1783080"/>
+            <a:ext cx="1339596" cy="475488"/>
           </a:xfrm>
           <a:prstGeom prst="roundRect">
             <a:avLst>
@@ -3160,20 +3396,20 @@
         </p:nvSpPr>
         <p:spPr>
           <a:xfrm>
-            <a:off x="4887468" y="1783080"/>
-            <a:ext cx="1824228" cy="475488"/>
-          </a:xfrm>
-          <a:prstGeom prst="rect">
-            <a:avLst/>
-          </a:prstGeom>
-          <a:noFill/>
-          <a:ln/>
-        </p:spPr>
-        <p:txBody>
-          <a:bodyPr wrap="square" lIns="0" tIns="0" rIns="0" bIns="0" rtlCol="0" anchor="ctr"/>
-          <a:lstStyle/>
-          <a:p>
-            <a:pPr marL="0" indent="0" algn="ctr">
+            <a:off x="3456432" y="1783080"/>
+            <a:ext cx="1339596" cy="475488"/>
+          </a:xfrm>
+          <a:prstGeom prst="rect">
+            <a:avLst/>
+          </a:prstGeom>
+          <a:noFill/>
+          <a:ln/>
+        </p:spPr>
+        <p:txBody>
+          <a:bodyPr wrap="square" lIns="0" tIns="0" rIns="0" bIns="0" rtlCol="0" anchor="ctr"/>
+          <a:lstStyle/>
+          <a:p>
+            <a:pPr algn="ctr" indent="0" marL="0">
               <a:buNone/>
             </a:pPr>
             <a:r>
@@ -3185,7 +3421,7 @@
                 <a:ea typeface="Segoe UI" pitchFamily="34" charset="-122"/>
                 <a:cs typeface="Segoe UI" pitchFamily="34" charset="-120"/>
               </a:rPr>
-              <a:t>Tailwind CSS v4</a:t>
+              <a:t>Tailwind v4</a:t>
             </a:r>
             <a:endParaRPr lang="en-US" sz="1200" dirty="0"/>
           </a:p>
@@ -3199,8 +3435,8 @@
         </p:nvSpPr>
         <p:spPr>
           <a:xfrm>
-            <a:off x="6912864" y="1783080"/>
-            <a:ext cx="2784348" cy="475488"/>
+            <a:off x="4997196" y="1783080"/>
+            <a:ext cx="1600200" cy="475488"/>
           </a:xfrm>
           <a:prstGeom prst="roundRect">
             <a:avLst>
@@ -3226,20 +3462,20 @@
         </p:nvSpPr>
         <p:spPr>
           <a:xfrm>
-            <a:off x="6912864" y="1783080"/>
-            <a:ext cx="2784348" cy="475488"/>
-          </a:xfrm>
-          <a:prstGeom prst="rect">
-            <a:avLst/>
-          </a:prstGeom>
-          <a:noFill/>
-          <a:ln/>
-        </p:spPr>
-        <p:txBody>
-          <a:bodyPr wrap="square" lIns="0" tIns="0" rIns="0" bIns="0" rtlCol="0" anchor="ctr"/>
-          <a:lstStyle/>
-          <a:p>
-            <a:pPr marL="0" indent="0" algn="ctr">
+            <a:off x="4997196" y="1783080"/>
+            <a:ext cx="1600200" cy="475488"/>
+          </a:xfrm>
+          <a:prstGeom prst="rect">
+            <a:avLst/>
+          </a:prstGeom>
+          <a:noFill/>
+          <a:ln/>
+        </p:spPr>
+        <p:txBody>
+          <a:bodyPr wrap="square" lIns="0" tIns="0" rIns="0" bIns="0" rtlCol="0" anchor="ctr"/>
+          <a:lstStyle/>
+          <a:p>
+            <a:pPr algn="ctr" indent="0" marL="0">
               <a:buNone/>
             </a:pPr>
             <a:r>
@@ -3251,7 +3487,7 @@
                 <a:ea typeface="Segoe UI" pitchFamily="34" charset="-122"/>
                 <a:cs typeface="Segoe UI" pitchFamily="34" charset="-120"/>
               </a:rPr>
-              <a:t>Zustand live order engine</a:t>
+              <a:t>Zustand engine</a:t>
             </a:r>
             <a:endParaRPr lang="en-US" sz="1200" dirty="0"/>
           </a:p>
@@ -3265,8 +3501,8 @@
         </p:nvSpPr>
         <p:spPr>
           <a:xfrm>
-            <a:off x="9898380" y="1783080"/>
-            <a:ext cx="1632204" cy="475488"/>
+            <a:off x="6798564" y="1783080"/>
+            <a:ext cx="1513332" cy="475488"/>
           </a:xfrm>
           <a:prstGeom prst="roundRect">
             <a:avLst>
@@ -3292,20 +3528,20 @@
         </p:nvSpPr>
         <p:spPr>
           <a:xfrm>
-            <a:off x="9898380" y="1783080"/>
-            <a:ext cx="1632204" cy="475488"/>
-          </a:xfrm>
-          <a:prstGeom prst="rect">
-            <a:avLst/>
-          </a:prstGeom>
-          <a:noFill/>
-          <a:ln/>
-        </p:spPr>
-        <p:txBody>
-          <a:bodyPr wrap="square" lIns="0" tIns="0" rIns="0" bIns="0" rtlCol="0" anchor="ctr"/>
-          <a:lstStyle/>
-          <a:p>
-            <a:pPr marL="0" indent="0" algn="ctr">
+            <a:off x="6798564" y="1783080"/>
+            <a:ext cx="1513332" cy="475488"/>
+          </a:xfrm>
+          <a:prstGeom prst="rect">
+            <a:avLst/>
+          </a:prstGeom>
+          <a:noFill/>
+          <a:ln/>
+        </p:spPr>
+        <p:txBody>
+          <a:bodyPr wrap="square" lIns="0" tIns="0" rIns="0" bIns="0" rtlCol="0" anchor="ctr"/>
+          <a:lstStyle/>
+          <a:p>
+            <a:pPr algn="ctr" indent="0" marL="0">
               <a:buNone/>
             </a:pPr>
             <a:r>
@@ -3331,8 +3567,8 @@
         </p:nvSpPr>
         <p:spPr>
           <a:xfrm>
-            <a:off x="11731752" y="1783080"/>
-            <a:ext cx="1152144" cy="475488"/>
+            <a:off x="8513064" y="1783080"/>
+            <a:ext cx="905256" cy="475488"/>
           </a:xfrm>
           <a:prstGeom prst="roundRect">
             <a:avLst>
@@ -3358,20 +3594,20 @@
         </p:nvSpPr>
         <p:spPr>
           <a:xfrm>
-            <a:off x="11731752" y="1783080"/>
-            <a:ext cx="1152144" cy="475488"/>
-          </a:xfrm>
-          <a:prstGeom prst="rect">
-            <a:avLst/>
-          </a:prstGeom>
-          <a:noFill/>
-          <a:ln/>
-        </p:spPr>
-        <p:txBody>
-          <a:bodyPr wrap="square" lIns="0" tIns="0" rIns="0" bIns="0" rtlCol="0" anchor="ctr"/>
-          <a:lstStyle/>
-          <a:p>
-            <a:pPr marL="0" indent="0" algn="ctr">
+            <a:off x="8513064" y="1783080"/>
+            <a:ext cx="905256" cy="475488"/>
+          </a:xfrm>
+          <a:prstGeom prst="rect">
+            <a:avLst/>
+          </a:prstGeom>
+          <a:noFill/>
+          <a:ln/>
+        </p:spPr>
+        <p:txBody>
+          <a:bodyPr wrap="square" lIns="0" tIns="0" rIns="0" bIns="0" rtlCol="0" anchor="ctr"/>
+          <a:lstStyle/>
+          <a:p>
+            <a:pPr algn="ctr" indent="0" marL="0">
               <a:buNone/>
             </a:pPr>
             <a:r>
@@ -3383,7 +3619,7 @@
                 <a:ea typeface="Segoe UI" pitchFamily="34" charset="-122"/>
                 <a:cs typeface="Segoe UI" pitchFamily="34" charset="-120"/>
               </a:rPr>
-              <a:t>Recharts</a:t>
+              <a:t>Vercel</a:t>
             </a:r>
             <a:endParaRPr lang="en-US" sz="1200" dirty="0"/>
           </a:p>
@@ -3391,73 +3627,7 @@
       </p:sp>
       <p:sp>
         <p:nvSpPr>
-          <p:cNvPr id="16" name="Shape 14"/>
-          <p:cNvSpPr/>
-          <p:nvPr/>
-        </p:nvSpPr>
-        <p:spPr>
-          <a:xfrm>
-            <a:off x="13085064" y="1783080"/>
-            <a:ext cx="2112264" cy="475488"/>
-          </a:xfrm>
-          <a:prstGeom prst="roundRect">
-            <a:avLst>
-              <a:gd name="adj" fmla="val 50000"/>
-            </a:avLst>
-          </a:prstGeom>
-          <a:solidFill>
-            <a:srgbClr val="FFFFFF"/>
-          </a:solidFill>
-          <a:ln w="12700">
-            <a:solidFill>
-              <a:srgbClr val="D7E0E7"/>
-            </a:solidFill>
-            <a:prstDash val="solid"/>
-          </a:ln>
-        </p:spPr>
-      </p:sp>
-      <p:sp>
-        <p:nvSpPr>
-          <p:cNvPr id="17" name="Text 15"/>
-          <p:cNvSpPr/>
-          <p:nvPr/>
-        </p:nvSpPr>
-        <p:spPr>
-          <a:xfrm>
-            <a:off x="13085064" y="1783080"/>
-            <a:ext cx="2112264" cy="475488"/>
-          </a:xfrm>
-          <a:prstGeom prst="rect">
-            <a:avLst/>
-          </a:prstGeom>
-          <a:noFill/>
-          <a:ln/>
-        </p:spPr>
-        <p:txBody>
-          <a:bodyPr wrap="square" lIns="0" tIns="0" rIns="0" bIns="0" rtlCol="0" anchor="ctr"/>
-          <a:lstStyle/>
-          <a:p>
-            <a:pPr marL="0" indent="0" algn="ctr">
-              <a:buNone/>
-            </a:pPr>
-            <a:r>
-              <a:rPr lang="en-US" sz="1200" b="1" dirty="0">
-                <a:solidFill>
-                  <a:srgbClr val="047857"/>
-                </a:solidFill>
-                <a:latin typeface="Segoe UI" pitchFamily="34" charset="0"/>
-                <a:ea typeface="Segoe UI" pitchFamily="34" charset="-122"/>
-                <a:cs typeface="Segoe UI" pitchFamily="34" charset="-120"/>
-              </a:rPr>
-              <a:t>Deployed on Vercel</a:t>
-            </a:r>
-            <a:endParaRPr lang="en-US" sz="1200" dirty="0"/>
-          </a:p>
-        </p:txBody>
-      </p:sp>
-      <p:sp>
-        <p:nvSpPr>
-          <p:cNvPr id="18" name="Text 16"/>
+          <p:cNvPr id="16" name="Text 14"/>
           <p:cNvSpPr/>
           <p:nvPr/>
         </p:nvSpPr>
@@ -3476,7 +3646,7 @@
           <a:bodyPr wrap="square" lIns="0" tIns="0" rIns="0" bIns="0" rtlCol="0" anchor="ctr"/>
           <a:lstStyle/>
           <a:p>
-            <a:pPr marL="0" indent="0">
+            <a:pPr indent="0" marL="0">
               <a:buNone/>
             </a:pPr>
             <a:r>
@@ -3496,7 +3666,7 @@
       </p:sp>
       <p:sp>
         <p:nvSpPr>
-          <p:cNvPr id="19" name="Shape 17"/>
+          <p:cNvPr id="17" name="Shape 15"/>
           <p:cNvSpPr/>
           <p:nvPr/>
         </p:nvSpPr>
@@ -3519,7 +3689,7 @@
       </p:sp>
       <p:sp>
         <p:nvSpPr>
-          <p:cNvPr id="20" name="Shape 18"/>
+          <p:cNvPr id="18" name="Shape 16"/>
           <p:cNvSpPr/>
           <p:nvPr/>
         </p:nvSpPr>
@@ -3539,7 +3709,7 @@
       </p:sp>
       <p:sp>
         <p:nvSpPr>
-          <p:cNvPr id="21" name="Text 19"/>
+          <p:cNvPr id="19" name="Text 17"/>
           <p:cNvSpPr/>
           <p:nvPr/>
         </p:nvSpPr>
@@ -3558,7 +3728,7 @@
           <a:bodyPr wrap="square" lIns="0" tIns="0" rIns="0" bIns="0" rtlCol="0" anchor="ctr"/>
           <a:lstStyle/>
           <a:p>
-            <a:pPr marL="0" indent="0" algn="ctr">
+            <a:pPr algn="ctr" indent="0" marL="0">
               <a:buNone/>
             </a:pPr>
             <a:r>
@@ -3578,13 +3748,13 @@
       </p:sp>
       <p:sp>
         <p:nvSpPr>
-          <p:cNvPr id="22" name="Text 20"/>
-          <p:cNvSpPr/>
-          <p:nvPr/>
-        </p:nvSpPr>
-        <p:spPr>
-          <a:xfrm>
-            <a:off x="1115568" y="3429000"/>
+          <p:cNvPr id="20" name="Text 18"/>
+          <p:cNvSpPr/>
+          <p:nvPr/>
+        </p:nvSpPr>
+        <p:spPr>
+          <a:xfrm>
+            <a:off x="1115568" y="3319272"/>
             <a:ext cx="2011680" cy="292608"/>
           </a:xfrm>
           <a:prstGeom prst="rect">
@@ -3597,7 +3767,7 @@
           <a:bodyPr wrap="square" lIns="0" tIns="0" rIns="0" bIns="0" rtlCol="0" anchor="ctr"/>
           <a:lstStyle/>
           <a:p>
-            <a:pPr marL="0" indent="0">
+            <a:pPr indent="0" marL="0">
               <a:buNone/>
             </a:pPr>
             <a:r>
@@ -3617,7 +3787,7 @@
       </p:sp>
       <p:sp>
         <p:nvSpPr>
-          <p:cNvPr id="23" name="Text 21"/>
+          <p:cNvPr id="21" name="Text 19"/>
           <p:cNvSpPr/>
           <p:nvPr/>
         </p:nvSpPr>
@@ -3636,7 +3806,7 @@
           <a:bodyPr wrap="square" lIns="0" tIns="0" rIns="0" bIns="0" rtlCol="0" anchor="ctr"/>
           <a:lstStyle/>
           <a:p>
-            <a:pPr marL="0" indent="0">
+            <a:pPr indent="0" marL="0">
               <a:spcAft>
                 <a:spcPts val="500"/>
               </a:spcAft>
@@ -3656,7 +3826,7 @@
             <a:endParaRPr lang="en-US" sz="1500" dirty="0"/>
           </a:p>
           <a:p>
-            <a:pPr marL="0" indent="0">
+            <a:pPr indent="0" marL="0">
               <a:spcAft>
                 <a:spcPts val="500"/>
               </a:spcAft>
@@ -3679,7 +3849,7 @@
       </p:sp>
       <p:sp>
         <p:nvSpPr>
-          <p:cNvPr id="24" name="Shape 22"/>
+          <p:cNvPr id="22" name="Shape 20"/>
           <p:cNvSpPr/>
           <p:nvPr/>
         </p:nvSpPr>
@@ -3702,7 +3872,7 @@
       </p:sp>
       <p:sp>
         <p:nvSpPr>
-          <p:cNvPr id="25" name="Shape 23"/>
+          <p:cNvPr id="23" name="Shape 21"/>
           <p:cNvSpPr/>
           <p:nvPr/>
         </p:nvSpPr>
@@ -3722,7 +3892,7 @@
       </p:sp>
       <p:sp>
         <p:nvSpPr>
-          <p:cNvPr id="26" name="Text 24"/>
+          <p:cNvPr id="24" name="Text 22"/>
           <p:cNvSpPr/>
           <p:nvPr/>
         </p:nvSpPr>
@@ -3741,7 +3911,7 @@
           <a:bodyPr wrap="square" lIns="0" tIns="0" rIns="0" bIns="0" rtlCol="0" anchor="ctr"/>
           <a:lstStyle/>
           <a:p>
-            <a:pPr marL="0" indent="0" algn="ctr">
+            <a:pPr algn="ctr" indent="0" marL="0">
               <a:buNone/>
             </a:pPr>
             <a:r>
@@ -3761,13 +3931,13 @@
       </p:sp>
       <p:sp>
         <p:nvSpPr>
-          <p:cNvPr id="27" name="Text 25"/>
-          <p:cNvSpPr/>
-          <p:nvPr/>
-        </p:nvSpPr>
-        <p:spPr>
-          <a:xfrm>
-            <a:off x="3977640" y="3383280"/>
+          <p:cNvPr id="25" name="Text 23"/>
+          <p:cNvSpPr/>
+          <p:nvPr/>
+        </p:nvSpPr>
+        <p:spPr>
+          <a:xfrm>
+            <a:off x="3977640" y="3319272"/>
             <a:ext cx="2011680" cy="292608"/>
           </a:xfrm>
           <a:prstGeom prst="rect">
@@ -3780,7 +3950,7 @@
           <a:bodyPr wrap="square" lIns="0" tIns="0" rIns="0" bIns="0" rtlCol="0" anchor="ctr"/>
           <a:lstStyle/>
           <a:p>
-            <a:pPr marL="0" indent="0">
+            <a:pPr indent="0" marL="0">
               <a:buNone/>
             </a:pPr>
             <a:r>
@@ -3800,7 +3970,7 @@
       </p:sp>
       <p:sp>
         <p:nvSpPr>
-          <p:cNvPr id="28" name="Text 26"/>
+          <p:cNvPr id="26" name="Text 24"/>
           <p:cNvSpPr/>
           <p:nvPr/>
         </p:nvSpPr>
@@ -3819,7 +3989,7 @@
           <a:bodyPr wrap="square" lIns="0" tIns="0" rIns="0" bIns="0" rtlCol="0" anchor="ctr"/>
           <a:lstStyle/>
           <a:p>
-            <a:pPr marL="0" indent="0">
+            <a:pPr indent="0" marL="0">
               <a:spcAft>
                 <a:spcPts val="500"/>
               </a:spcAft>
@@ -3839,7 +4009,7 @@
             <a:endParaRPr lang="en-US" sz="1500" dirty="0"/>
           </a:p>
           <a:p>
-            <a:pPr marL="0" indent="0">
+            <a:pPr indent="0" marL="0">
               <a:spcAft>
                 <a:spcPts val="500"/>
               </a:spcAft>
@@ -3862,13 +4032,13 @@
       </p:sp>
       <p:sp>
         <p:nvSpPr>
-          <p:cNvPr id="29" name="Shape 27"/>
-          <p:cNvSpPr/>
-          <p:nvPr/>
-        </p:nvSpPr>
-        <p:spPr>
-          <a:xfrm>
-            <a:off x="6665735" y="3414562"/>
+          <p:cNvPr id="27" name="Shape 25"/>
+          <p:cNvSpPr/>
+          <p:nvPr/>
+        </p:nvSpPr>
+        <p:spPr>
+          <a:xfrm>
+            <a:off x="6547104" y="3429000"/>
             <a:ext cx="2286000" cy="0"/>
           </a:xfrm>
           <a:prstGeom prst="line">
@@ -3885,7 +4055,7 @@
       </p:sp>
       <p:sp>
         <p:nvSpPr>
-          <p:cNvPr id="30" name="Shape 28"/>
+          <p:cNvPr id="28" name="Shape 26"/>
           <p:cNvSpPr/>
           <p:nvPr/>
         </p:nvSpPr>
@@ -3905,7 +4075,7 @@
       </p:sp>
       <p:sp>
         <p:nvSpPr>
-          <p:cNvPr id="31" name="Text 29"/>
+          <p:cNvPr id="29" name="Text 27"/>
           <p:cNvSpPr/>
           <p:nvPr/>
         </p:nvSpPr>
@@ -3924,7 +4094,7 @@
           <a:bodyPr wrap="square" lIns="0" tIns="0" rIns="0" bIns="0" rtlCol="0" anchor="ctr"/>
           <a:lstStyle/>
           <a:p>
-            <a:pPr marL="0" indent="0" algn="ctr">
+            <a:pPr algn="ctr" indent="0" marL="0">
               <a:buNone/>
             </a:pPr>
             <a:r>
@@ -3944,13 +4114,13 @@
       </p:sp>
       <p:sp>
         <p:nvSpPr>
-          <p:cNvPr id="32" name="Text 30"/>
-          <p:cNvSpPr/>
-          <p:nvPr/>
-        </p:nvSpPr>
-        <p:spPr>
-          <a:xfrm>
-            <a:off x="6839712" y="3404616"/>
+          <p:cNvPr id="30" name="Text 28"/>
+          <p:cNvSpPr/>
+          <p:nvPr/>
+        </p:nvSpPr>
+        <p:spPr>
+          <a:xfrm>
+            <a:off x="6839712" y="3319272"/>
             <a:ext cx="2011680" cy="292608"/>
           </a:xfrm>
           <a:prstGeom prst="rect">
@@ -3963,7 +4133,7 @@
           <a:bodyPr wrap="square" lIns="0" tIns="0" rIns="0" bIns="0" rtlCol="0" anchor="ctr"/>
           <a:lstStyle/>
           <a:p>
-            <a:pPr marL="0" indent="0">
+            <a:pPr indent="0" marL="0">
               <a:buNone/>
             </a:pPr>
             <a:r>
@@ -3983,7 +4153,7 @@
       </p:sp>
       <p:sp>
         <p:nvSpPr>
-          <p:cNvPr id="33" name="Text 31"/>
+          <p:cNvPr id="31" name="Text 29"/>
           <p:cNvSpPr/>
           <p:nvPr/>
         </p:nvSpPr>
@@ -4002,7 +4172,7 @@
           <a:bodyPr wrap="square" lIns="0" tIns="0" rIns="0" bIns="0" rtlCol="0" anchor="ctr"/>
           <a:lstStyle/>
           <a:p>
-            <a:pPr marL="0" indent="0">
+            <a:pPr indent="0" marL="0">
               <a:spcAft>
                 <a:spcPts val="500"/>
               </a:spcAft>
@@ -4022,7 +4192,7 @@
             <a:endParaRPr lang="en-US" sz="1500" dirty="0"/>
           </a:p>
           <a:p>
-            <a:pPr marL="0" indent="0">
+            <a:pPr indent="0" marL="0">
               <a:spcAft>
                 <a:spcPts val="500"/>
               </a:spcAft>
@@ -4045,13 +4215,13 @@
       </p:sp>
       <p:sp>
         <p:nvSpPr>
-          <p:cNvPr id="34" name="Shape 32"/>
-          <p:cNvSpPr/>
-          <p:nvPr/>
-        </p:nvSpPr>
-        <p:spPr>
-          <a:xfrm>
-            <a:off x="9409176" y="3404616"/>
+          <p:cNvPr id="32" name="Shape 30"/>
+          <p:cNvSpPr/>
+          <p:nvPr/>
+        </p:nvSpPr>
+        <p:spPr>
+          <a:xfrm>
+            <a:off x="9409176" y="3429000"/>
             <a:ext cx="2286000" cy="0"/>
           </a:xfrm>
           <a:prstGeom prst="line">
@@ -4068,7 +4238,7 @@
       </p:sp>
       <p:sp>
         <p:nvSpPr>
-          <p:cNvPr id="35" name="Shape 33"/>
+          <p:cNvPr id="33" name="Shape 31"/>
           <p:cNvSpPr/>
           <p:nvPr/>
         </p:nvSpPr>
@@ -4088,7 +4258,7 @@
       </p:sp>
       <p:sp>
         <p:nvSpPr>
-          <p:cNvPr id="36" name="Text 34"/>
+          <p:cNvPr id="34" name="Text 32"/>
           <p:cNvSpPr/>
           <p:nvPr/>
         </p:nvSpPr>
@@ -4107,7 +4277,7 @@
           <a:bodyPr wrap="square" lIns="0" tIns="0" rIns="0" bIns="0" rtlCol="0" anchor="ctr"/>
           <a:lstStyle/>
           <a:p>
-            <a:pPr marL="0" indent="0" algn="ctr">
+            <a:pPr algn="ctr" indent="0" marL="0">
               <a:buNone/>
             </a:pPr>
             <a:r>
@@ -4127,13 +4297,13 @@
       </p:sp>
       <p:sp>
         <p:nvSpPr>
-          <p:cNvPr id="37" name="Text 35"/>
-          <p:cNvSpPr/>
-          <p:nvPr/>
-        </p:nvSpPr>
-        <p:spPr>
-          <a:xfrm>
-            <a:off x="9701784" y="3381195"/>
+          <p:cNvPr id="35" name="Text 33"/>
+          <p:cNvSpPr/>
+          <p:nvPr/>
+        </p:nvSpPr>
+        <p:spPr>
+          <a:xfrm>
+            <a:off x="9701784" y="3319272"/>
             <a:ext cx="2011680" cy="292608"/>
           </a:xfrm>
           <a:prstGeom prst="rect">
@@ -4146,7 +4316,7 @@
           <a:bodyPr wrap="square" lIns="0" tIns="0" rIns="0" bIns="0" rtlCol="0" anchor="ctr"/>
           <a:lstStyle/>
           <a:p>
-            <a:pPr marL="0" indent="0">
+            <a:pPr indent="0" marL="0">
               <a:buNone/>
             </a:pPr>
             <a:r>
@@ -4166,7 +4336,7 @@
       </p:sp>
       <p:sp>
         <p:nvSpPr>
-          <p:cNvPr id="38" name="Text 36"/>
+          <p:cNvPr id="36" name="Text 34"/>
           <p:cNvSpPr/>
           <p:nvPr/>
         </p:nvSpPr>
@@ -4185,7 +4355,7 @@
           <a:bodyPr wrap="square" lIns="0" tIns="0" rIns="0" bIns="0" rtlCol="0" anchor="ctr"/>
           <a:lstStyle/>
           <a:p>
-            <a:pPr marL="0" indent="0">
+            <a:pPr indent="0" marL="0">
               <a:spcAft>
                 <a:spcPts val="500"/>
               </a:spcAft>
@@ -4205,7 +4375,7 @@
             <a:endParaRPr lang="en-US" sz="1500" dirty="0"/>
           </a:p>
           <a:p>
-            <a:pPr marL="0" indent="0">
+            <a:pPr indent="0" marL="0">
               <a:spcAft>
                 <a:spcPts val="500"/>
               </a:spcAft>
@@ -4228,7 +4398,7 @@
       </p:sp>
       <p:sp>
         <p:nvSpPr>
-          <p:cNvPr id="39" name="Text 37"/>
+          <p:cNvPr id="37" name="Text 35"/>
           <p:cNvSpPr/>
           <p:nvPr/>
         </p:nvSpPr>
@@ -4247,7 +4417,7 @@
           <a:bodyPr wrap="square" lIns="0" tIns="0" rIns="0" bIns="0" rtlCol="0" anchor="ctr"/>
           <a:lstStyle/>
           <a:p>
-            <a:pPr marL="0" indent="0">
+            <a:pPr indent="0" marL="0">
               <a:buNone/>
             </a:pPr>
             <a:r>
@@ -4267,7 +4437,7 @@
       </p:sp>
       <p:sp>
         <p:nvSpPr>
-          <p:cNvPr id="40" name="Text 38"/>
+          <p:cNvPr id="38" name="Text 36"/>
           <p:cNvSpPr/>
           <p:nvPr/>
         </p:nvSpPr>
@@ -4286,7 +4456,7 @@
           <a:bodyPr wrap="square" lIns="0" tIns="0" rIns="0" bIns="0" rtlCol="0" anchor="ctr"/>
           <a:lstStyle/>
           <a:p>
-            <a:pPr marL="0" indent="0" algn="r">
+            <a:pPr algn="r" indent="0" marL="0">
               <a:buNone/>
             </a:pPr>
             <a:r>
@@ -4320,7 +4490,6 @@
         <a:solidFill>
           <a:srgbClr val="0B111E"/>
         </a:solidFill>
-        <a:effectLst/>
       </p:bgPr>
     </p:bg>
     <p:spTree>
@@ -4339,14 +4508,14 @@
       </p:grpSpPr>
       <p:pic>
         <p:nvPicPr>
-          <p:cNvPr id="2" name="Image 0" descr="C:/Users/Aryan/Downloads/1image.png"/>
+          <p:cNvPr id="2" name="Image 0" descr="C:/Users/Aryan/Downloads/1image.png">    </p:cNvPr>
           <p:cNvPicPr>
             <a:picLocks noChangeAspect="1"/>
           </p:cNvPicPr>
           <p:nvPr/>
         </p:nvPicPr>
         <p:blipFill>
-          <a:blip r:embed="rId3"/>
+          <a:blip r:embed="rId1"/>
           <a:stretch>
             <a:fillRect/>
           </a:stretch>
@@ -4382,7 +4551,7 @@
           <a:bodyPr wrap="square" lIns="0" tIns="0" rIns="0" bIns="0" rtlCol="0" anchor="ctr"/>
           <a:lstStyle/>
           <a:p>
-            <a:pPr marL="0" indent="0">
+            <a:pPr indent="0" marL="0">
               <a:buNone/>
             </a:pPr>
             <a:r>
@@ -4421,7 +4590,7 @@
           <a:bodyPr wrap="square" lIns="0" tIns="0" rIns="0" bIns="0" rtlCol="0" anchor="ctr"/>
           <a:lstStyle/>
           <a:p>
-            <a:pPr marL="0" indent="0">
+            <a:pPr indent="0" marL="0">
               <a:buNone/>
             </a:pPr>
             <a:r>
@@ -4435,6 +4604,9 @@
               </a:rPr>
               <a:t>NearKart — </a:t>
             </a:r>
+            <a:pPr indent="0" marL="0">
+              <a:buNone/>
+            </a:pPr>
             <a:r>
               <a:rPr lang="en-US" sz="2000" dirty="0">
                 <a:solidFill>
@@ -4471,7 +4643,7 @@
           <a:bodyPr wrap="square" lIns="0" tIns="0" rIns="0" bIns="0" rtlCol="0" anchor="ctr"/>
           <a:lstStyle/>
           <a:p>
-            <a:pPr marL="0" indent="0">
+            <a:pPr indent="0" marL="0">
               <a:spcAft>
                 <a:spcPts val="800"/>
               </a:spcAft>
@@ -4488,21 +4660,7 @@
               </a:rPr>
               <a:t>Aryan Patel</a:t>
             </a:r>
-            <a:r>
-              <a:rPr lang="en-US" sz="1400" dirty="0">
-                <a:solidFill>
-                  <a:srgbClr val="9FB0C0"/>
-                </a:solidFill>
-                <a:latin typeface="Segoe UI" pitchFamily="34" charset="0"/>
-                <a:ea typeface="Segoe UI" pitchFamily="34" charset="-122"/>
-                <a:cs typeface="Segoe UI" pitchFamily="34" charset="-120"/>
-              </a:rPr>
-              <a:t>   Computer Engineering · ENO 240753107021</a:t>
-            </a:r>
-            <a:endParaRPr lang="en-US" sz="1600" dirty="0"/>
-          </a:p>
-          <a:p>
-            <a:pPr marL="0" indent="0">
+            <a:pPr indent="0" marL="0">
               <a:spcAft>
                 <a:spcPts val="800"/>
               </a:spcAft>
@@ -4517,40 +4675,72 @@
                 <a:ea typeface="Segoe UI" pitchFamily="34" charset="-122"/>
                 <a:cs typeface="Segoe UI" pitchFamily="34" charset="-120"/>
               </a:rPr>
-              <a:t>Guided by </a:t>
-            </a:r>
-            <a:r>
-              <a:rPr lang="en-US" sz="1400" b="1" dirty="0">
-                <a:solidFill>
-                  <a:srgbClr val="FFFFFF"/>
-                </a:solidFill>
-                <a:latin typeface="Segoe UI" pitchFamily="34" charset="0"/>
-                <a:ea typeface="Segoe UI" pitchFamily="34" charset="-122"/>
-                <a:cs typeface="Segoe UI" pitchFamily="34" charset="-120"/>
-              </a:rPr>
-              <a:t>Dr. Anil Suthar</a:t>
-            </a:r>
-            <a:r>
-              <a:rPr lang="en-US" sz="1400" dirty="0">
-                <a:solidFill>
-                  <a:srgbClr val="9FB0C0"/>
-                </a:solidFill>
-                <a:latin typeface="Segoe UI" pitchFamily="34" charset="0"/>
-                <a:ea typeface="Segoe UI" pitchFamily="34" charset="-122"/>
-                <a:cs typeface="Segoe UI" pitchFamily="34" charset="-120"/>
-              </a:rPr>
-              <a:t>, Principal</a:t>
+              <a:t>   Computer Engineering · ENO 240753107021</a:t>
             </a:r>
             <a:endParaRPr lang="en-US" sz="1600" dirty="0"/>
           </a:p>
           <a:p>
-            <a:pPr marL="0" indent="0">
+            <a:pPr indent="0" marL="0">
               <a:spcAft>
                 <a:spcPts val="800"/>
               </a:spcAft>
               <a:buNone/>
             </a:pPr>
             <a:r>
+              <a:rPr lang="en-US" sz="1400" dirty="0">
+                <a:solidFill>
+                  <a:srgbClr val="9FB0C0"/>
+                </a:solidFill>
+                <a:latin typeface="Segoe UI" pitchFamily="34" charset="0"/>
+                <a:ea typeface="Segoe UI" pitchFamily="34" charset="-122"/>
+                <a:cs typeface="Segoe UI" pitchFamily="34" charset="-120"/>
+              </a:rPr>
+              <a:t>Guided by </a:t>
+            </a:r>
+            <a:pPr indent="0" marL="0">
+              <a:spcAft>
+                <a:spcPts val="800"/>
+              </a:spcAft>
+              <a:buNone/>
+            </a:pPr>
+            <a:r>
+              <a:rPr lang="en-US" sz="1400" b="1" dirty="0">
+                <a:solidFill>
+                  <a:srgbClr val="FFFFFF"/>
+                </a:solidFill>
+                <a:latin typeface="Segoe UI" pitchFamily="34" charset="0"/>
+                <a:ea typeface="Segoe UI" pitchFamily="34" charset="-122"/>
+                <a:cs typeface="Segoe UI" pitchFamily="34" charset="-120"/>
+              </a:rPr>
+              <a:t>Dr. Anil Suthar</a:t>
+            </a:r>
+            <a:pPr indent="0" marL="0">
+              <a:spcAft>
+                <a:spcPts val="800"/>
+              </a:spcAft>
+              <a:buNone/>
+            </a:pPr>
+            <a:r>
+              <a:rPr lang="en-US" sz="1400" dirty="0">
+                <a:solidFill>
+                  <a:srgbClr val="9FB0C0"/>
+                </a:solidFill>
+                <a:latin typeface="Segoe UI" pitchFamily="34" charset="0"/>
+                <a:ea typeface="Segoe UI" pitchFamily="34" charset="-122"/>
+                <a:cs typeface="Segoe UI" pitchFamily="34" charset="-120"/>
+              </a:rPr>
+              <a:t>, Principal</a:t>
+            </a:r>
+            <a:endParaRPr lang="en-US" sz="1600" dirty="0"/>
+          </a:p>
+          <a:p>
+            <a:pPr indent="0" marL="0">
+              <a:spcAft>
+                <a:spcPts val="800"/>
+              </a:spcAft>
+              <a:buNone/>
+            </a:pPr>
+            <a:r>
               <a:rPr lang="en-US" sz="1300" dirty="0">
                 <a:solidFill>
                   <a:srgbClr val="9FB0C0"/>
@@ -4567,14 +4757,14 @@
       </p:sp>
       <p:pic>
         <p:nvPicPr>
-          <p:cNvPr id="6" name="Image 1" descr="C:/Users/Aryan/Desktop/Nearcart/docs_build/qr.png"/>
+          <p:cNvPr id="6" name="Image 1" descr="C:/Users/Aryan/Desktop/Nearcart/docs_build/qr.png">    </p:cNvPr>
           <p:cNvPicPr>
             <a:picLocks noChangeAspect="1"/>
           </p:cNvPicPr>
           <p:nvPr/>
         </p:nvPicPr>
         <p:blipFill>
-          <a:blip r:embed="rId4"/>
+          <a:blip r:embed="rId2"/>
           <a:stretch>
             <a:fillRect/>
           </a:stretch>
@@ -4610,7 +4800,7 @@
           <a:bodyPr wrap="square" lIns="0" tIns="0" rIns="0" bIns="0" rtlCol="0" anchor="ctr"/>
           <a:lstStyle/>
           <a:p>
-            <a:pPr marL="0" indent="0" algn="ctr">
+            <a:pPr algn="ctr" indent="0" marL="0">
               <a:buNone/>
             </a:pPr>
             <a:r>
@@ -4630,14 +4820,14 @@
       </p:sp>
       <p:pic>
         <p:nvPicPr>
-          <p:cNvPr id="8" name="Image 2" descr="C:/Users/Aryan/Downloads/image.png"/>
+          <p:cNvPr id="8" name="Image 2" descr="C:/Users/Aryan/Downloads/image.png">    </p:cNvPr>
           <p:cNvPicPr>
             <a:picLocks noChangeAspect="1"/>
           </p:cNvPicPr>
           <p:nvPr/>
         </p:nvPicPr>
         <p:blipFill>
-          <a:blip r:embed="rId5"/>
+          <a:blip r:embed="rId3"/>
           <a:stretch>
             <a:fillRect/>
           </a:stretch>
@@ -4668,7 +4858,6 @@
         <a:solidFill>
           <a:srgbClr val="F6F8F9"/>
         </a:solidFill>
-        <a:effectLst/>
       </p:bgPr>
     </p:bg>
     <p:spTree>
@@ -4706,11 +4895,11 @@
           <a:bodyPr wrap="square" lIns="0" tIns="0" rIns="0" bIns="0" rtlCol="0" anchor="ctr"/>
           <a:lstStyle/>
           <a:p>
-            <a:pPr marL="0" indent="0">
-              <a:buNone/>
-            </a:pPr>
-            <a:r>
-              <a:rPr lang="en-US" sz="1200" b="1" kern="0" spc="300" dirty="0">
+            <a:pPr indent="0" marL="0">
+              <a:buNone/>
+            </a:pPr>
+            <a:r>
+              <a:rPr lang="en-US" sz="1200" b="1" spc="300" kern="0" dirty="0">
                 <a:solidFill>
                   <a:srgbClr val="059669"/>
                 </a:solidFill>
@@ -4745,7 +4934,7 @@
           <a:bodyPr wrap="square" lIns="0" tIns="0" rIns="0" bIns="0" rtlCol="0" anchor="ctr"/>
           <a:lstStyle/>
           <a:p>
-            <a:pPr marL="0" indent="0">
+            <a:pPr indent="0" marL="0">
               <a:buNone/>
             </a:pPr>
             <a:r>
@@ -4786,7 +4975,7 @@
           <a:bodyPr wrap="square" lIns="0" tIns="0" rIns="0" bIns="0" rtlCol="0" anchor="ctr"/>
           <a:lstStyle/>
           <a:p>
-            <a:pPr marL="0" indent="0" algn="ctr">
+            <a:pPr algn="ctr" indent="0" marL="0">
               <a:buNone/>
             </a:pPr>
             <a:r>
@@ -4825,7 +5014,7 @@
           <a:bodyPr wrap="square" lIns="0" tIns="0" rIns="0" bIns="0" rtlCol="0" anchor="ctr"/>
           <a:lstStyle/>
           <a:p>
-            <a:pPr marL="0" indent="0">
+            <a:pPr indent="0" marL="0">
               <a:spcAft>
                 <a:spcPts val="400"/>
               </a:spcAft>
@@ -4845,7 +5034,7 @@
             <a:endParaRPr lang="en-US" sz="1400" dirty="0"/>
           </a:p>
           <a:p>
-            <a:pPr marL="0" indent="0">
+            <a:pPr indent="0" marL="0">
               <a:spcAft>
                 <a:spcPts val="400"/>
               </a:spcAft>
@@ -4889,7 +5078,7 @@
           <a:bodyPr wrap="square" lIns="0" tIns="0" rIns="0" bIns="0" rtlCol="0" anchor="ctr"/>
           <a:lstStyle/>
           <a:p>
-            <a:pPr marL="0" indent="0" algn="ctr">
+            <a:pPr algn="ctr" indent="0" marL="0">
               <a:buNone/>
             </a:pPr>
             <a:r>
@@ -4928,7 +5117,7 @@
           <a:bodyPr wrap="square" lIns="0" tIns="0" rIns="0" bIns="0" rtlCol="0" anchor="ctr"/>
           <a:lstStyle/>
           <a:p>
-            <a:pPr marL="0" indent="0">
+            <a:pPr indent="0" marL="0">
               <a:spcAft>
                 <a:spcPts val="400"/>
               </a:spcAft>
@@ -4948,7 +5137,7 @@
             <a:endParaRPr lang="en-US" sz="1400" dirty="0"/>
           </a:p>
           <a:p>
-            <a:pPr marL="0" indent="0">
+            <a:pPr indent="0" marL="0">
               <a:spcAft>
                 <a:spcPts val="400"/>
               </a:spcAft>
@@ -4992,7 +5181,7 @@
           <a:bodyPr wrap="square" lIns="0" tIns="0" rIns="0" bIns="0" rtlCol="0" anchor="ctr"/>
           <a:lstStyle/>
           <a:p>
-            <a:pPr marL="0" indent="0" algn="ctr">
+            <a:pPr algn="ctr" indent="0" marL="0">
               <a:buNone/>
             </a:pPr>
             <a:r>
@@ -5031,7 +5220,7 @@
           <a:bodyPr wrap="square" lIns="0" tIns="0" rIns="0" bIns="0" rtlCol="0" anchor="ctr"/>
           <a:lstStyle/>
           <a:p>
-            <a:pPr marL="0" indent="0">
+            <a:pPr indent="0" marL="0">
               <a:spcAft>
                 <a:spcPts val="400"/>
               </a:spcAft>
@@ -5051,7 +5240,7 @@
             <a:endParaRPr lang="en-US" sz="1400" dirty="0"/>
           </a:p>
           <a:p>
-            <a:pPr marL="0" indent="0">
+            <a:pPr indent="0" marL="0">
               <a:spcAft>
                 <a:spcPts val="400"/>
               </a:spcAft>
@@ -5098,7 +5287,7 @@
             <a:prstDash val="solid"/>
           </a:ln>
           <a:effectLst>
-            <a:outerShdw blurRad="114300" dist="38100" dir="2700000" algn="bl" rotWithShape="0">
+            <a:outerShdw sx="100000" sy="100000" kx="0" ky="0" algn="bl" rotWithShape="0" blurRad="114300" dist="38100" dir="2700000">
               <a:srgbClr val="0A1220">
                 <a:alpha val="22000"/>
               </a:srgbClr>
@@ -5127,7 +5316,7 @@
           <a:bodyPr wrap="square" lIns="0" tIns="0" rIns="0" bIns="0" rtlCol="0" anchor="ctr"/>
           <a:lstStyle/>
           <a:p>
-            <a:pPr marL="0" indent="0">
+            <a:pPr indent="0" marL="0">
               <a:spcAft>
                 <a:spcPts val="300"/>
               </a:spcAft>
@@ -5147,7 +5336,7 @@
             <a:endParaRPr lang="en-US" sz="3000" dirty="0"/>
           </a:p>
           <a:p>
-            <a:pPr marL="0" indent="0">
+            <a:pPr indent="0" marL="0">
               <a:spcAft>
                 <a:spcPts val="300"/>
               </a:spcAft>
@@ -5164,6 +5353,12 @@
               </a:rPr>
               <a:t>kirana stores in India — </a:t>
             </a:r>
+            <a:pPr indent="0" marL="0">
+              <a:spcAft>
+                <a:spcPts val="300"/>
+              </a:spcAft>
+              <a:buNone/>
+            </a:pPr>
             <a:r>
               <a:rPr lang="en-US" sz="1250" dirty="0">
                 <a:solidFill>
@@ -5205,7 +5400,7 @@
             <a:prstDash val="solid"/>
           </a:ln>
           <a:effectLst>
-            <a:outerShdw blurRad="114300" dist="38100" dir="2700000" algn="bl" rotWithShape="0">
+            <a:outerShdw sx="100000" sy="100000" kx="0" ky="0" algn="bl" rotWithShape="0" blurRad="114300" dist="38100" dir="2700000">
               <a:srgbClr val="0A1220">
                 <a:alpha val="22000"/>
               </a:srgbClr>
@@ -5234,7 +5429,7 @@
           <a:bodyPr wrap="square" lIns="0" tIns="0" rIns="0" bIns="0" rtlCol="0" anchor="ctr"/>
           <a:lstStyle/>
           <a:p>
-            <a:pPr marL="0" indent="0">
+            <a:pPr indent="0" marL="0">
               <a:spcAft>
                 <a:spcPts val="300"/>
               </a:spcAft>
@@ -5254,7 +5449,7 @@
             <a:endParaRPr lang="en-US" sz="3000" dirty="0"/>
           </a:p>
           <a:p>
-            <a:pPr marL="0" indent="0">
+            <a:pPr indent="0" marL="0">
               <a:spcAft>
                 <a:spcPts val="300"/>
               </a:spcAft>
@@ -5271,6 +5466,12 @@
               </a:rPr>
               <a:t>SKUs per dark store — </a:t>
             </a:r>
+            <a:pPr indent="0" marL="0">
+              <a:spcAft>
+                <a:spcPts val="300"/>
+              </a:spcAft>
+              <a:buNone/>
+            </a:pPr>
             <a:r>
               <a:rPr lang="en-US" sz="1250" dirty="0">
                 <a:solidFill>
@@ -5312,7 +5513,7 @@
             <a:prstDash val="solid"/>
           </a:ln>
           <a:effectLst>
-            <a:outerShdw blurRad="114300" dist="38100" dir="2700000" algn="bl" rotWithShape="0">
+            <a:outerShdw sx="100000" sy="100000" kx="0" ky="0" algn="bl" rotWithShape="0" blurRad="114300" dist="38100" dir="2700000">
               <a:srgbClr val="0A1220">
                 <a:alpha val="22000"/>
               </a:srgbClr>
@@ -5341,7 +5542,7 @@
           <a:bodyPr wrap="square" lIns="0" tIns="0" rIns="0" bIns="0" rtlCol="0" anchor="ctr"/>
           <a:lstStyle/>
           <a:p>
-            <a:pPr marL="0" indent="0">
+            <a:pPr indent="0" marL="0">
               <a:spcAft>
                 <a:spcPts val="300"/>
               </a:spcAft>
@@ -5361,7 +5562,7 @@
             <a:endParaRPr lang="en-US" sz="3000" dirty="0"/>
           </a:p>
           <a:p>
-            <a:pPr marL="0" indent="0">
+            <a:pPr indent="0" marL="0">
               <a:spcAft>
                 <a:spcPts val="300"/>
               </a:spcAft>
@@ -5378,6 +5579,12 @@
               </a:rPr>
               <a:t>typical profit per order — </a:t>
             </a:r>
+            <a:pPr indent="0" marL="0">
+              <a:spcAft>
+                <a:spcPts val="300"/>
+              </a:spcAft>
+              <a:buNone/>
+            </a:pPr>
             <a:r>
               <a:rPr lang="en-US" sz="1250" dirty="0">
                 <a:solidFill>
@@ -5414,7 +5621,7 @@
           <a:bodyPr wrap="square" lIns="0" tIns="0" rIns="0" bIns="0" rtlCol="0" anchor="ctr"/>
           <a:lstStyle/>
           <a:p>
-            <a:pPr marL="0" indent="0">
+            <a:pPr indent="0" marL="0">
               <a:buNone/>
             </a:pPr>
             <a:r>
@@ -5453,7 +5660,7 @@
           <a:bodyPr wrap="square" lIns="0" tIns="0" rIns="0" bIns="0" rtlCol="0" anchor="ctr"/>
           <a:lstStyle/>
           <a:p>
-            <a:pPr marL="0" indent="0" algn="r">
+            <a:pPr algn="r" indent="0" marL="0">
               <a:buNone/>
             </a:pPr>
             <a:r>
@@ -5487,7 +5694,6 @@
         <a:solidFill>
           <a:srgbClr val="F6F8F9"/>
         </a:solidFill>
-        <a:effectLst/>
       </p:bgPr>
     </p:bg>
     <p:spTree>
@@ -5525,11 +5731,11 @@
           <a:bodyPr wrap="square" lIns="0" tIns="0" rIns="0" bIns="0" rtlCol="0" anchor="ctr"/>
           <a:lstStyle/>
           <a:p>
-            <a:pPr marL="0" indent="0">
-              <a:buNone/>
-            </a:pPr>
-            <a:r>
-              <a:rPr lang="en-US" sz="1200" b="1" kern="0" spc="300" dirty="0">
+            <a:pPr indent="0" marL="0">
+              <a:buNone/>
+            </a:pPr>
+            <a:r>
+              <a:rPr lang="en-US" sz="1200" b="1" spc="300" kern="0" dirty="0">
                 <a:solidFill>
                   <a:srgbClr val="059669"/>
                 </a:solidFill>
@@ -5564,7 +5770,7 @@
           <a:bodyPr wrap="square" lIns="0" tIns="0" rIns="0" bIns="0" rtlCol="0" anchor="ctr"/>
           <a:lstStyle/>
           <a:p>
-            <a:pPr marL="0" indent="0">
+            <a:pPr indent="0" marL="0">
               <a:buNone/>
             </a:pPr>
             <a:r>
@@ -5603,7 +5809,7 @@
           <a:bodyPr wrap="square" lIns="0" tIns="0" rIns="0" bIns="0" rtlCol="0" anchor="ctr"/>
           <a:lstStyle/>
           <a:p>
-            <a:pPr marL="0" indent="0">
+            <a:pPr indent="0" marL="0">
               <a:buNone/>
             </a:pPr>
             <a:r>
@@ -5647,7 +5853,7 @@
             <a:prstDash val="solid"/>
           </a:ln>
           <a:effectLst>
-            <a:outerShdw blurRad="114300" dist="38100" dir="2700000" algn="bl" rotWithShape="0">
+            <a:outerShdw sx="100000" sy="100000" kx="0" ky="0" algn="bl" rotWithShape="0" blurRad="114300" dist="38100" dir="2700000">
               <a:srgbClr val="0A1220">
                 <a:alpha val="22000"/>
               </a:srgbClr>
@@ -5696,7 +5902,7 @@
           <a:bodyPr wrap="square" lIns="0" tIns="0" rIns="0" bIns="0" rtlCol="0" anchor="ctr"/>
           <a:lstStyle/>
           <a:p>
-            <a:pPr marL="0" indent="0" algn="ctr">
+            <a:pPr algn="ctr" indent="0" marL="0">
               <a:buNone/>
             </a:pPr>
             <a:r>
@@ -5735,7 +5941,7 @@
           <a:bodyPr wrap="square" lIns="0" tIns="0" rIns="0" bIns="0" rtlCol="0" anchor="ctr"/>
           <a:lstStyle/>
           <a:p>
-            <a:pPr marL="0" indent="0">
+            <a:pPr indent="0" marL="0">
               <a:buNone/>
             </a:pPr>
             <a:r>
@@ -5774,7 +5980,7 @@
           <a:bodyPr wrap="square" lIns="0" tIns="0" rIns="0" bIns="0" rtlCol="0" anchor="ctr"/>
           <a:lstStyle/>
           <a:p>
-            <a:pPr marL="0" indent="0">
+            <a:pPr indent="0" marL="0">
               <a:buNone/>
             </a:pPr>
             <a:r>
@@ -5813,7 +6019,7 @@
           <a:bodyPr wrap="square" lIns="0" tIns="0" rIns="0" bIns="0" rtlCol="0" anchor="ctr"/>
           <a:lstStyle/>
           <a:p>
-            <a:pPr marL="0" indent="0" algn="ctr">
+            <a:pPr algn="ctr" indent="0" marL="0">
               <a:buNone/>
             </a:pPr>
             <a:r>
@@ -5857,7 +6063,7 @@
             <a:prstDash val="solid"/>
           </a:ln>
           <a:effectLst>
-            <a:outerShdw blurRad="114300" dist="38100" dir="2700000" algn="bl" rotWithShape="0">
+            <a:outerShdw sx="100000" sy="100000" kx="0" ky="0" algn="bl" rotWithShape="0" blurRad="114300" dist="38100" dir="2700000">
               <a:srgbClr val="0A1220">
                 <a:alpha val="22000"/>
               </a:srgbClr>
@@ -5906,7 +6112,7 @@
           <a:bodyPr wrap="square" lIns="0" tIns="0" rIns="0" bIns="0" rtlCol="0" anchor="ctr"/>
           <a:lstStyle/>
           <a:p>
-            <a:pPr marL="0" indent="0" algn="ctr">
+            <a:pPr algn="ctr" indent="0" marL="0">
               <a:buNone/>
             </a:pPr>
             <a:r>
@@ -5945,7 +6151,7 @@
           <a:bodyPr wrap="square" lIns="0" tIns="0" rIns="0" bIns="0" rtlCol="0" anchor="ctr"/>
           <a:lstStyle/>
           <a:p>
-            <a:pPr marL="0" indent="0">
+            <a:pPr indent="0" marL="0">
               <a:buNone/>
             </a:pPr>
             <a:r>
@@ -5984,7 +6190,7 @@
           <a:bodyPr wrap="square" lIns="0" tIns="0" rIns="0" bIns="0" rtlCol="0" anchor="ctr"/>
           <a:lstStyle/>
           <a:p>
-            <a:pPr marL="0" indent="0">
+            <a:pPr indent="0" marL="0">
               <a:buNone/>
             </a:pPr>
             <a:r>
@@ -6023,7 +6229,7 @@
           <a:bodyPr wrap="square" lIns="0" tIns="0" rIns="0" bIns="0" rtlCol="0" anchor="ctr"/>
           <a:lstStyle/>
           <a:p>
-            <a:pPr marL="0" indent="0" algn="ctr">
+            <a:pPr algn="ctr" indent="0" marL="0">
               <a:buNone/>
             </a:pPr>
             <a:r>
@@ -6067,7 +6273,7 @@
             <a:prstDash val="solid"/>
           </a:ln>
           <a:effectLst>
-            <a:outerShdw blurRad="114300" dist="38100" dir="2700000" algn="bl" rotWithShape="0">
+            <a:outerShdw sx="100000" sy="100000" kx="0" ky="0" algn="bl" rotWithShape="0" blurRad="114300" dist="38100" dir="2700000">
               <a:srgbClr val="0A1220">
                 <a:alpha val="22000"/>
               </a:srgbClr>
@@ -6116,7 +6322,7 @@
           <a:bodyPr wrap="square" lIns="0" tIns="0" rIns="0" bIns="0" rtlCol="0" anchor="ctr"/>
           <a:lstStyle/>
           <a:p>
-            <a:pPr marL="0" indent="0" algn="ctr">
+            <a:pPr algn="ctr" indent="0" marL="0">
               <a:buNone/>
             </a:pPr>
             <a:r>
@@ -6155,7 +6361,7 @@
           <a:bodyPr wrap="square" lIns="0" tIns="0" rIns="0" bIns="0" rtlCol="0" anchor="ctr"/>
           <a:lstStyle/>
           <a:p>
-            <a:pPr marL="0" indent="0">
+            <a:pPr indent="0" marL="0">
               <a:buNone/>
             </a:pPr>
             <a:r>
@@ -6194,7 +6400,7 @@
           <a:bodyPr wrap="square" lIns="0" tIns="0" rIns="0" bIns="0" rtlCol="0" anchor="ctr"/>
           <a:lstStyle/>
           <a:p>
-            <a:pPr marL="0" indent="0">
+            <a:pPr indent="0" marL="0">
               <a:buNone/>
             </a:pPr>
             <a:r>
@@ -6233,7 +6439,7 @@
           <a:bodyPr wrap="square" lIns="0" tIns="0" rIns="0" bIns="0" rtlCol="0" anchor="ctr"/>
           <a:lstStyle/>
           <a:p>
-            <a:pPr marL="0" indent="0" algn="ctr">
+            <a:pPr algn="ctr" indent="0" marL="0">
               <a:buNone/>
             </a:pPr>
             <a:r>
@@ -6277,7 +6483,7 @@
             <a:prstDash val="solid"/>
           </a:ln>
           <a:effectLst>
-            <a:outerShdw blurRad="114300" dist="38100" dir="2700000" algn="bl" rotWithShape="0">
+            <a:outerShdw sx="100000" sy="100000" kx="0" ky="0" algn="bl" rotWithShape="0" blurRad="114300" dist="38100" dir="2700000">
               <a:srgbClr val="0A1220">
                 <a:alpha val="22000"/>
               </a:srgbClr>
@@ -6326,7 +6532,7 @@
           <a:bodyPr wrap="square" lIns="0" tIns="0" rIns="0" bIns="0" rtlCol="0" anchor="ctr"/>
           <a:lstStyle/>
           <a:p>
-            <a:pPr marL="0" indent="0" algn="ctr">
+            <a:pPr algn="ctr" indent="0" marL="0">
               <a:buNone/>
             </a:pPr>
             <a:r>
@@ -6365,7 +6571,7 @@
           <a:bodyPr wrap="square" lIns="0" tIns="0" rIns="0" bIns="0" rtlCol="0" anchor="ctr"/>
           <a:lstStyle/>
           <a:p>
-            <a:pPr marL="0" indent="0">
+            <a:pPr indent="0" marL="0">
               <a:buNone/>
             </a:pPr>
             <a:r>
@@ -6404,7 +6610,7 @@
           <a:bodyPr wrap="square" lIns="0" tIns="0" rIns="0" bIns="0" rtlCol="0" anchor="ctr"/>
           <a:lstStyle/>
           <a:p>
-            <a:pPr marL="0" indent="0">
+            <a:pPr indent="0" marL="0">
               <a:buNone/>
             </a:pPr>
             <a:r>
@@ -6465,7 +6671,7 @@
           <a:bodyPr wrap="square" lIns="0" tIns="0" rIns="0" bIns="0" rtlCol="0" anchor="ctr"/>
           <a:lstStyle/>
           <a:p>
-            <a:pPr marL="0" indent="0">
+            <a:pPr indent="0" marL="0">
               <a:buNone/>
             </a:pPr>
             <a:r>
@@ -6479,6 +6685,9 @@
               </a:rPr>
               <a:t>One shared live order engine.  </a:t>
             </a:r>
+            <a:pPr indent="0" marL="0">
+              <a:buNone/>
+            </a:pPr>
             <a:r>
               <a:rPr lang="en-US" sz="1350" dirty="0">
                 <a:solidFill>
@@ -6515,7 +6724,7 @@
           <a:bodyPr wrap="square" lIns="0" tIns="0" rIns="0" bIns="0" rtlCol="0" anchor="ctr"/>
           <a:lstStyle/>
           <a:p>
-            <a:pPr marL="0" indent="0" algn="r">
+            <a:pPr algn="r" indent="0" marL="0">
               <a:buNone/>
             </a:pPr>
             <a:r>
@@ -6549,7 +6758,6 @@
         <a:solidFill>
           <a:srgbClr val="F6F8F9"/>
         </a:solidFill>
-        <a:effectLst/>
       </p:bgPr>
     </p:bg>
     <p:spTree>
@@ -6587,11 +6795,11 @@
           <a:bodyPr wrap="square" lIns="0" tIns="0" rIns="0" bIns="0" rtlCol="0" anchor="ctr"/>
           <a:lstStyle/>
           <a:p>
-            <a:pPr marL="0" indent="0">
-              <a:buNone/>
-            </a:pPr>
-            <a:r>
-              <a:rPr lang="en-US" sz="1200" b="1" kern="0" spc="300" dirty="0">
+            <a:pPr indent="0" marL="0">
+              <a:buNone/>
+            </a:pPr>
+            <a:r>
+              <a:rPr lang="en-US" sz="1200" b="1" spc="300" kern="0" dirty="0">
                 <a:solidFill>
                   <a:srgbClr val="059669"/>
                 </a:solidFill>
@@ -6626,7 +6834,7 @@
           <a:bodyPr wrap="square" lIns="0" tIns="0" rIns="0" bIns="0" rtlCol="0" anchor="ctr"/>
           <a:lstStyle/>
           <a:p>
-            <a:pPr marL="0" indent="0">
+            <a:pPr indent="0" marL="0">
               <a:buNone/>
             </a:pPr>
             <a:r>
@@ -6646,14 +6854,14 @@
       </p:sp>
       <p:pic>
         <p:nvPicPr>
-          <p:cNvPr id="4" name="Image 0" descr="C:/Users/Aryan/Desktop/Nearcart/docs_build/shots/customer.png"/>
+          <p:cNvPr id="4" name="Image 0" descr="C:/Users/Aryan/Desktop/Nearcart/docs_build/shots/customer.png">    </p:cNvPr>
           <p:cNvPicPr>
             <a:picLocks noChangeAspect="1"/>
           </p:cNvPicPr>
           <p:nvPr/>
         </p:nvPicPr>
         <p:blipFill>
-          <a:blip r:embed="rId3"/>
+          <a:blip r:embed="rId1"/>
           <a:stretch>
             <a:fillRect/>
           </a:stretch>
@@ -6667,7 +6875,7 @@
             <a:avLst/>
           </a:prstGeom>
           <a:effectLst>
-            <a:outerShdw blurRad="114300" dist="38100" dir="2700000" algn="bl" rotWithShape="0">
+            <a:outerShdw sx="100000" sy="100000" kx="0" ky="0" algn="bl" rotWithShape="0" blurRad="114300" dist="38100" dir="2700000">
               <a:srgbClr val="0A1220">
                 <a:alpha val="22000"/>
               </a:srgbClr>
@@ -6696,7 +6904,7 @@
           <a:bodyPr wrap="square" lIns="0" tIns="0" rIns="0" bIns="0" rtlCol="0" anchor="ctr"/>
           <a:lstStyle/>
           <a:p>
-            <a:pPr marL="0" indent="0">
+            <a:pPr indent="0" marL="0">
               <a:buNone/>
             </a:pPr>
             <a:r>
@@ -6735,7 +6943,7 @@
           <a:bodyPr wrap="square" lIns="0" tIns="0" rIns="0" bIns="0" rtlCol="0" anchor="t"/>
           <a:lstStyle/>
           <a:p>
-            <a:pPr marL="0" indent="0">
+            <a:pPr indent="0" marL="0">
               <a:buNone/>
             </a:pPr>
             <a:r>
@@ -6749,6 +6957,9 @@
               </a:rPr>
               <a:t>Smart ranking.  </a:t>
             </a:r>
+            <a:pPr indent="0" marL="0">
+              <a:buNone/>
+            </a:pPr>
             <a:r>
               <a:rPr lang="en-US" sz="1350" dirty="0">
                 <a:solidFill>
@@ -6785,7 +6996,7 @@
           <a:bodyPr wrap="square" lIns="0" tIns="0" rIns="0" bIns="0" rtlCol="0" anchor="t"/>
           <a:lstStyle/>
           <a:p>
-            <a:pPr marL="0" indent="0">
+            <a:pPr indent="0" marL="0">
               <a:buNone/>
             </a:pPr>
             <a:r>
@@ -6799,6 +7010,9 @@
               </a:rPr>
               <a:t>Honest basket building.  </a:t>
             </a:r>
+            <a:pPr indent="0" marL="0">
+              <a:buNone/>
+            </a:pPr>
             <a:r>
               <a:rPr lang="en-US" sz="1350" dirty="0">
                 <a:solidFill>
@@ -6835,7 +7049,7 @@
           <a:bodyPr wrap="square" lIns="0" tIns="0" rIns="0" bIns="0" rtlCol="0" anchor="t"/>
           <a:lstStyle/>
           <a:p>
-            <a:pPr marL="0" indent="0">
+            <a:pPr indent="0" marL="0">
               <a:buNone/>
             </a:pPr>
             <a:r>
@@ -6849,6 +7063,9 @@
               </a:rPr>
               <a:t>Live tracking.  </a:t>
             </a:r>
+            <a:pPr indent="0" marL="0">
+              <a:buNone/>
+            </a:pPr>
             <a:r>
               <a:rPr lang="en-US" sz="1350" dirty="0">
                 <a:solidFill>
@@ -6885,7 +7102,7 @@
           <a:bodyPr wrap="square" lIns="0" tIns="0" rIns="0" bIns="0" rtlCol="0" anchor="t"/>
           <a:lstStyle/>
           <a:p>
-            <a:pPr marL="0" indent="0">
+            <a:pPr indent="0" marL="0">
               <a:buNone/>
             </a:pPr>
             <a:r>
@@ -6899,6 +7116,9 @@
               </a:rPr>
               <a:t>Loyalty that sticks.  </a:t>
             </a:r>
+            <a:pPr indent="0" marL="0">
+              <a:buNone/>
+            </a:pPr>
             <a:r>
               <a:rPr lang="en-US" sz="1350" dirty="0">
                 <a:solidFill>
@@ -6935,7 +7155,7 @@
           <a:bodyPr wrap="square" lIns="0" tIns="0" rIns="0" bIns="0" rtlCol="0" anchor="t"/>
           <a:lstStyle/>
           <a:p>
-            <a:pPr marL="0" indent="0">
+            <a:pPr indent="0" marL="0">
               <a:buNone/>
             </a:pPr>
             <a:r>
@@ -6949,6 +7169,9 @@
               </a:rPr>
               <a:t>Real urgency only.  </a:t>
             </a:r>
+            <a:pPr indent="0" marL="0">
+              <a:buNone/>
+            </a:pPr>
             <a:r>
               <a:rPr lang="en-US" sz="1350" dirty="0">
                 <a:solidFill>
@@ -6985,7 +7208,7 @@
           <a:bodyPr wrap="square" lIns="0" tIns="0" rIns="0" bIns="0" rtlCol="0" anchor="ctr"/>
           <a:lstStyle/>
           <a:p>
-            <a:pPr marL="0" indent="0" algn="r">
+            <a:pPr algn="r" indent="0" marL="0">
               <a:buNone/>
             </a:pPr>
             <a:r>
@@ -7019,7 +7242,6 @@
         <a:solidFill>
           <a:srgbClr val="F6F8F9"/>
         </a:solidFill>
-        <a:effectLst/>
       </p:bgPr>
     </p:bg>
     <p:spTree>
@@ -7057,11 +7279,11 @@
           <a:bodyPr wrap="square" lIns="0" tIns="0" rIns="0" bIns="0" rtlCol="0" anchor="ctr"/>
           <a:lstStyle/>
           <a:p>
-            <a:pPr marL="0" indent="0">
-              <a:buNone/>
-            </a:pPr>
-            <a:r>
-              <a:rPr lang="en-US" sz="1200" b="1" kern="0" spc="300" dirty="0">
+            <a:pPr indent="0" marL="0">
+              <a:buNone/>
+            </a:pPr>
+            <a:r>
+              <a:rPr lang="en-US" sz="1200" b="1" spc="300" kern="0" dirty="0">
                 <a:solidFill>
                   <a:srgbClr val="059669"/>
                 </a:solidFill>
@@ -7096,7 +7318,7 @@
           <a:bodyPr wrap="square" lIns="0" tIns="0" rIns="0" bIns="0" rtlCol="0" anchor="ctr"/>
           <a:lstStyle/>
           <a:p>
-            <a:pPr marL="0" indent="0">
+            <a:pPr indent="0" marL="0">
               <a:buNone/>
             </a:pPr>
             <a:r>
@@ -7116,14 +7338,14 @@
       </p:sp>
       <p:pic>
         <p:nvPicPr>
-          <p:cNvPr id="4" name="Image 0" descr="C:/Users/Aryan/Desktop/Nearcart/docs_build/shots/shop.png"/>
+          <p:cNvPr id="4" name="Image 0" descr="C:/Users/Aryan/Desktop/Nearcart/docs_build/shots/shop.png">    </p:cNvPr>
           <p:cNvPicPr>
             <a:picLocks noChangeAspect="1"/>
           </p:cNvPicPr>
           <p:nvPr/>
         </p:nvPicPr>
         <p:blipFill>
-          <a:blip r:embed="rId3"/>
+          <a:blip r:embed="rId1"/>
           <a:stretch>
             <a:fillRect/>
           </a:stretch>
@@ -7137,7 +7359,7 @@
             <a:avLst/>
           </a:prstGeom>
           <a:effectLst>
-            <a:outerShdw blurRad="114300" dist="38100" dir="2700000" algn="bl" rotWithShape="0">
+            <a:outerShdw sx="100000" sy="100000" kx="0" ky="0" algn="bl" rotWithShape="0" blurRad="114300" dist="38100" dir="2700000">
               <a:srgbClr val="0A1220">
                 <a:alpha val="22000"/>
               </a:srgbClr>
@@ -7166,7 +7388,7 @@
           <a:bodyPr wrap="square" lIns="0" tIns="0" rIns="0" bIns="0" rtlCol="0" anchor="ctr"/>
           <a:lstStyle/>
           <a:p>
-            <a:pPr marL="0" indent="0">
+            <a:pPr indent="0" marL="0">
               <a:buNone/>
             </a:pPr>
             <a:r>
@@ -7205,7 +7427,7 @@
           <a:bodyPr wrap="square" lIns="0" tIns="0" rIns="0" bIns="0" rtlCol="0" anchor="t"/>
           <a:lstStyle/>
           <a:p>
-            <a:pPr marL="0" indent="0">
+            <a:pPr indent="0" marL="0">
               <a:buNone/>
             </a:pPr>
             <a:r>
@@ -7219,6 +7441,9 @@
               </a:rPr>
               <a:t>2-minute accept timer.  </a:t>
             </a:r>
+            <a:pPr indent="0" marL="0">
+              <a:buNone/>
+            </a:pPr>
             <a:r>
               <a:rPr lang="en-US" sz="1350" dirty="0">
                 <a:solidFill>
@@ -7255,7 +7480,7 @@
           <a:bodyPr wrap="square" lIns="0" tIns="0" rIns="0" bIns="0" rtlCol="0" anchor="t"/>
           <a:lstStyle/>
           <a:p>
-            <a:pPr marL="0" indent="0">
+            <a:pPr indent="0" marL="0">
               <a:buNone/>
             </a:pPr>
             <a:r>
@@ -7269,6 +7494,9 @@
               </a:rPr>
               <a:t>Inventory automation.  </a:t>
             </a:r>
+            <a:pPr indent="0" marL="0">
+              <a:buNone/>
+            </a:pPr>
             <a:r>
               <a:rPr lang="en-US" sz="1350" dirty="0">
                 <a:solidFill>
@@ -7305,7 +7533,7 @@
           <a:bodyPr wrap="square" lIns="0" tIns="0" rIns="0" bIns="0" rtlCol="0" anchor="t"/>
           <a:lstStyle/>
           <a:p>
-            <a:pPr marL="0" indent="0">
+            <a:pPr indent="0" marL="0">
               <a:buNone/>
             </a:pPr>
             <a:r>
@@ -7319,6 +7547,9 @@
               </a:rPr>
               <a:t>Transparent payouts.  </a:t>
             </a:r>
+            <a:pPr indent="0" marL="0">
+              <a:buNone/>
+            </a:pPr>
             <a:r>
               <a:rPr lang="en-US" sz="1350" dirty="0">
                 <a:solidFill>
@@ -7355,7 +7586,7 @@
           <a:bodyPr wrap="square" lIns="0" tIns="0" rIns="0" bIns="0" rtlCol="0" anchor="t"/>
           <a:lstStyle/>
           <a:p>
-            <a:pPr marL="0" indent="0">
+            <a:pPr indent="0" marL="0">
               <a:buNone/>
             </a:pPr>
             <a:r>
@@ -7369,6 +7600,9 @@
               </a:rPr>
               <a:t>Offers manager.  </a:t>
             </a:r>
+            <a:pPr indent="0" marL="0">
+              <a:buNone/>
+            </a:pPr>
             <a:r>
               <a:rPr lang="en-US" sz="1350" dirty="0">
                 <a:solidFill>
@@ -7405,7 +7639,7 @@
           <a:bodyPr wrap="square" lIns="0" tIns="0" rIns="0" bIns="0" rtlCol="0" anchor="t"/>
           <a:lstStyle/>
           <a:p>
-            <a:pPr marL="0" indent="0">
+            <a:pPr indent="0" marL="0">
               <a:buNone/>
             </a:pPr>
             <a:r>
@@ -7419,6 +7653,9 @@
               </a:rPr>
               <a:t>Availability control.  </a:t>
             </a:r>
+            <a:pPr indent="0" marL="0">
+              <a:buNone/>
+            </a:pPr>
             <a:r>
               <a:rPr lang="en-US" sz="1350" dirty="0">
                 <a:solidFill>
@@ -7455,7 +7692,7 @@
           <a:bodyPr wrap="square" lIns="0" tIns="0" rIns="0" bIns="0" rtlCol="0" anchor="ctr"/>
           <a:lstStyle/>
           <a:p>
-            <a:pPr marL="0" indent="0" algn="r">
+            <a:pPr algn="r" indent="0" marL="0">
               <a:buNone/>
             </a:pPr>
             <a:r>
@@ -7489,7 +7726,6 @@
         <a:solidFill>
           <a:srgbClr val="F6F8F9"/>
         </a:solidFill>
-        <a:effectLst/>
       </p:bgPr>
     </p:bg>
     <p:spTree>
@@ -7527,11 +7763,11 @@
           <a:bodyPr wrap="square" lIns="0" tIns="0" rIns="0" bIns="0" rtlCol="0" anchor="ctr"/>
           <a:lstStyle/>
           <a:p>
-            <a:pPr marL="0" indent="0">
-              <a:buNone/>
-            </a:pPr>
-            <a:r>
-              <a:rPr lang="en-US" sz="1200" b="1" kern="0" spc="300" dirty="0">
+            <a:pPr indent="0" marL="0">
+              <a:buNone/>
+            </a:pPr>
+            <a:r>
+              <a:rPr lang="en-US" sz="1200" b="1" spc="300" kern="0" dirty="0">
                 <a:solidFill>
                   <a:srgbClr val="059669"/>
                 </a:solidFill>
@@ -7566,7 +7802,7 @@
           <a:bodyPr wrap="square" lIns="0" tIns="0" rIns="0" bIns="0" rtlCol="0" anchor="ctr"/>
           <a:lstStyle/>
           <a:p>
-            <a:pPr marL="0" indent="0">
+            <a:pPr indent="0" marL="0">
               <a:buNone/>
             </a:pPr>
             <a:r>
@@ -7586,14 +7822,14 @@
       </p:sp>
       <p:pic>
         <p:nvPicPr>
-          <p:cNvPr id="4" name="Image 0" descr="C:/Users/Aryan/Desktop/Nearcart/docs_build/shots/rider.png"/>
+          <p:cNvPr id="4" name="Image 0" descr="C:/Users/Aryan/Desktop/Nearcart/docs_build/shots/rider.png">    </p:cNvPr>
           <p:cNvPicPr>
             <a:picLocks noChangeAspect="1"/>
           </p:cNvPicPr>
           <p:nvPr/>
         </p:nvPicPr>
         <p:blipFill>
-          <a:blip r:embed="rId3"/>
+          <a:blip r:embed="rId1"/>
           <a:stretch>
             <a:fillRect/>
           </a:stretch>
@@ -7607,7 +7843,7 @@
             <a:avLst/>
           </a:prstGeom>
           <a:effectLst>
-            <a:outerShdw blurRad="114300" dist="38100" dir="2700000" algn="bl" rotWithShape="0">
+            <a:outerShdw sx="100000" sy="100000" kx="0" ky="0" algn="bl" rotWithShape="0" blurRad="114300" dist="38100" dir="2700000">
               <a:srgbClr val="0A1220">
                 <a:alpha val="22000"/>
               </a:srgbClr>
@@ -7636,7 +7872,7 @@
           <a:bodyPr wrap="square" lIns="0" tIns="0" rIns="0" bIns="0" rtlCol="0" anchor="ctr"/>
           <a:lstStyle/>
           <a:p>
-            <a:pPr marL="0" indent="0">
+            <a:pPr indent="0" marL="0">
               <a:buNone/>
             </a:pPr>
             <a:r>
@@ -7675,7 +7911,7 @@
           <a:bodyPr wrap="square" lIns="0" tIns="0" rIns="0" bIns="0" rtlCol="0" anchor="ctr"/>
           <a:lstStyle/>
           <a:p>
-            <a:pPr marL="0" indent="0">
+            <a:pPr indent="0" marL="0">
               <a:buNone/>
             </a:pPr>
             <a:r>
@@ -7695,14 +7931,14 @@
       </p:sp>
       <p:pic>
         <p:nvPicPr>
-          <p:cNvPr id="7" name="Image 1" descr="C:/Users/Aryan/Desktop/Nearcart/docs_build/shots/admin.png"/>
+          <p:cNvPr id="7" name="Image 1" descr="C:/Users/Aryan/Desktop/Nearcart/docs_build/shots/admin.png">    </p:cNvPr>
           <p:cNvPicPr>
             <a:picLocks noChangeAspect="1"/>
           </p:cNvPicPr>
           <p:nvPr/>
         </p:nvPicPr>
         <p:blipFill>
-          <a:blip r:embed="rId4"/>
+          <a:blip r:embed="rId2"/>
           <a:stretch>
             <a:fillRect/>
           </a:stretch>
@@ -7716,7 +7952,7 @@
             <a:avLst/>
           </a:prstGeom>
           <a:effectLst>
-            <a:outerShdw blurRad="114300" dist="38100" dir="2700000" algn="bl" rotWithShape="0">
+            <a:outerShdw sx="100000" sy="100000" kx="0" ky="0" algn="bl" rotWithShape="0" blurRad="114300" dist="38100" dir="2700000">
               <a:srgbClr val="0A1220">
                 <a:alpha val="22000"/>
               </a:srgbClr>
@@ -7745,7 +7981,7 @@
           <a:bodyPr wrap="square" lIns="0" tIns="0" rIns="0" bIns="0" rtlCol="0" anchor="ctr"/>
           <a:lstStyle/>
           <a:p>
-            <a:pPr marL="0" indent="0">
+            <a:pPr indent="0" marL="0">
               <a:buNone/>
             </a:pPr>
             <a:r>
@@ -7784,7 +8020,7 @@
           <a:bodyPr wrap="square" lIns="0" tIns="0" rIns="0" bIns="0" rtlCol="0" anchor="ctr"/>
           <a:lstStyle/>
           <a:p>
-            <a:pPr marL="0" indent="0">
+            <a:pPr indent="0" marL="0">
               <a:buNone/>
             </a:pPr>
             <a:r>
@@ -7823,7 +8059,7 @@
           <a:bodyPr wrap="square" lIns="0" tIns="0" rIns="0" bIns="0" rtlCol="0" anchor="ctr"/>
           <a:lstStyle/>
           <a:p>
-            <a:pPr marL="0" indent="0" algn="r">
+            <a:pPr algn="r" indent="0" marL="0">
               <a:buNone/>
             </a:pPr>
             <a:r>
@@ -7857,7 +8093,6 @@
         <a:solidFill>
           <a:srgbClr val="0B111E"/>
         </a:solidFill>
-        <a:effectLst/>
       </p:bgPr>
     </p:bg>
     <p:spTree>
@@ -7895,11 +8130,11 @@
           <a:bodyPr wrap="square" lIns="0" tIns="0" rIns="0" bIns="0" rtlCol="0" anchor="ctr"/>
           <a:lstStyle/>
           <a:p>
-            <a:pPr marL="0" indent="0">
-              <a:buNone/>
-            </a:pPr>
-            <a:r>
-              <a:rPr lang="en-US" sz="1200" b="1" kern="0" spc="300" dirty="0">
+            <a:pPr indent="0" marL="0">
+              <a:buNone/>
+            </a:pPr>
+            <a:r>
+              <a:rPr lang="en-US" sz="1200" b="1" spc="300" kern="0" dirty="0">
                 <a:solidFill>
                   <a:srgbClr val="10B981"/>
                 </a:solidFill>
@@ -7934,7 +8169,7 @@
           <a:bodyPr wrap="square" lIns="0" tIns="0" rIns="0" bIns="0" rtlCol="0" anchor="ctr"/>
           <a:lstStyle/>
           <a:p>
-            <a:pPr marL="0" indent="0">
+            <a:pPr indent="0" marL="0">
               <a:buNone/>
             </a:pPr>
             <a:r>
@@ -7954,14 +8189,14 @@
       </p:sp>
       <p:pic>
         <p:nvPicPr>
-          <p:cNvPr id="4" name="Image 0" descr="C:/Users/Aryan/Desktop/Nearcart/docs_build/qr.png"/>
+          <p:cNvPr id="4" name="Image 0" descr="C:/Users/Aryan/Desktop/Nearcart/docs_build/qr.png">    </p:cNvPr>
           <p:cNvPicPr>
             <a:picLocks noChangeAspect="1"/>
           </p:cNvPicPr>
           <p:nvPr/>
         </p:nvPicPr>
         <p:blipFill>
-          <a:blip r:embed="rId3"/>
+          <a:blip r:embed="rId1"/>
           <a:stretch>
             <a:fillRect/>
           </a:stretch>
@@ -7997,7 +8232,7 @@
           <a:bodyPr wrap="square" lIns="0" tIns="0" rIns="0" bIns="0" rtlCol="0" anchor="ctr"/>
           <a:lstStyle/>
           <a:p>
-            <a:pPr marL="0" indent="0" algn="ctr">
+            <a:pPr algn="ctr" indent="0" marL="0">
               <a:buNone/>
             </a:pPr>
             <a:r>
@@ -8036,7 +8271,7 @@
           <a:bodyPr wrap="square" lIns="0" tIns="0" rIns="0" bIns="0" rtlCol="0" anchor="ctr"/>
           <a:lstStyle/>
           <a:p>
-            <a:pPr marL="0" indent="0" algn="ctr">
+            <a:pPr algn="ctr" indent="0" marL="0">
               <a:buNone/>
             </a:pPr>
             <a:r>
@@ -8102,7 +8337,7 @@
           <a:bodyPr wrap="square" lIns="0" tIns="0" rIns="0" bIns="0" rtlCol="0" anchor="ctr"/>
           <a:lstStyle/>
           <a:p>
-            <a:pPr marL="0" indent="0">
+            <a:pPr indent="0" marL="0">
               <a:buNone/>
             </a:pPr>
             <a:r>
@@ -8116,6 +8351,9 @@
               </a:rPr>
               <a:t>near-kart-iota.vercel.app</a:t>
             </a:r>
+            <a:pPr indent="0" marL="0">
+              <a:buNone/>
+            </a:pPr>
             <a:r>
               <a:rPr lang="en-US" sz="1500" b="1" dirty="0">
                 <a:solidFill>
@@ -8152,7 +8390,7 @@
           <a:bodyPr wrap="square" lIns="0" tIns="0" rIns="0" bIns="0" rtlCol="0" anchor="ctr"/>
           <a:lstStyle/>
           <a:p>
-            <a:pPr marL="0" indent="0">
+            <a:pPr indent="0" marL="0">
               <a:buNone/>
             </a:pPr>
             <a:r>
@@ -8169,7 +8407,7 @@
             <a:endParaRPr lang="en-US" sz="1400" dirty="0"/>
           </a:p>
           <a:p>
-            <a:pPr marL="0" indent="0">
+            <a:pPr indent="0" marL="0">
               <a:buNone/>
             </a:pPr>
             <a:r>
@@ -8235,7 +8473,7 @@
           <a:bodyPr wrap="square" lIns="0" tIns="0" rIns="0" bIns="0" rtlCol="0" anchor="ctr"/>
           <a:lstStyle/>
           <a:p>
-            <a:pPr marL="0" indent="0">
+            <a:pPr indent="0" marL="0">
               <a:buNone/>
             </a:pPr>
             <a:r>
@@ -8249,6 +8487,9 @@
               </a:rPr>
               <a:t>near-kart-iota.vercel.app</a:t>
             </a:r>
+            <a:pPr indent="0" marL="0">
+              <a:buNone/>
+            </a:pPr>
             <a:r>
               <a:rPr lang="en-US" sz="1500" b="1" dirty="0">
                 <a:solidFill>
@@ -8285,7 +8526,7 @@
           <a:bodyPr wrap="square" lIns="0" tIns="0" rIns="0" bIns="0" rtlCol="0" anchor="ctr"/>
           <a:lstStyle/>
           <a:p>
-            <a:pPr marL="0" indent="0">
+            <a:pPr indent="0" marL="0">
               <a:buNone/>
             </a:pPr>
             <a:r>
@@ -8302,7 +8543,7 @@
             <a:endParaRPr lang="en-US" sz="1400" dirty="0"/>
           </a:p>
           <a:p>
-            <a:pPr marL="0" indent="0">
+            <a:pPr indent="0" marL="0">
               <a:buNone/>
             </a:pPr>
             <a:r>
@@ -8368,7 +8609,7 @@
           <a:bodyPr wrap="square" lIns="0" tIns="0" rIns="0" bIns="0" rtlCol="0" anchor="ctr"/>
           <a:lstStyle/>
           <a:p>
-            <a:pPr marL="0" indent="0">
+            <a:pPr indent="0" marL="0">
               <a:buNone/>
             </a:pPr>
             <a:r>
@@ -8382,6 +8623,9 @@
               </a:rPr>
               <a:t>near-kart-iota.vercel.app</a:t>
             </a:r>
+            <a:pPr indent="0" marL="0">
+              <a:buNone/>
+            </a:pPr>
             <a:r>
               <a:rPr lang="en-US" sz="1500" b="1" dirty="0">
                 <a:solidFill>
@@ -8418,7 +8662,7 @@
           <a:bodyPr wrap="square" lIns="0" tIns="0" rIns="0" bIns="0" rtlCol="0" anchor="ctr"/>
           <a:lstStyle/>
           <a:p>
-            <a:pPr marL="0" indent="0">
+            <a:pPr indent="0" marL="0">
               <a:buNone/>
             </a:pPr>
             <a:r>
@@ -8435,7 +8679,7 @@
             <a:endParaRPr lang="en-US" sz="1400" dirty="0"/>
           </a:p>
           <a:p>
-            <a:pPr marL="0" indent="0">
+            <a:pPr indent="0" marL="0">
               <a:buNone/>
             </a:pPr>
             <a:r>
@@ -8501,7 +8745,7 @@
           <a:bodyPr wrap="square" lIns="0" tIns="0" rIns="0" bIns="0" rtlCol="0" anchor="ctr"/>
           <a:lstStyle/>
           <a:p>
-            <a:pPr marL="0" indent="0">
+            <a:pPr indent="0" marL="0">
               <a:buNone/>
             </a:pPr>
             <a:r>
@@ -8515,6 +8759,9 @@
               </a:rPr>
               <a:t>near-kart-iota.vercel.app</a:t>
             </a:r>
+            <a:pPr indent="0" marL="0">
+              <a:buNone/>
+            </a:pPr>
             <a:r>
               <a:rPr lang="en-US" sz="1500" b="1" dirty="0">
                 <a:solidFill>
@@ -8551,7 +8798,7 @@
           <a:bodyPr wrap="square" lIns="0" tIns="0" rIns="0" bIns="0" rtlCol="0" anchor="ctr"/>
           <a:lstStyle/>
           <a:p>
-            <a:pPr marL="0" indent="0">
+            <a:pPr indent="0" marL="0">
               <a:buNone/>
             </a:pPr>
             <a:r>
@@ -8568,7 +8815,7 @@
             <a:endParaRPr lang="en-US" sz="1400" dirty="0"/>
           </a:p>
           <a:p>
-            <a:pPr marL="0" indent="0">
+            <a:pPr indent="0" marL="0">
               <a:buNone/>
             </a:pPr>
             <a:r>
@@ -8607,7 +8854,7 @@
           <a:bodyPr wrap="square" lIns="0" tIns="0" rIns="0" bIns="0" rtlCol="0" anchor="ctr"/>
           <a:lstStyle/>
           <a:p>
-            <a:pPr marL="0" indent="0">
+            <a:pPr indent="0" marL="0">
               <a:buNone/>
             </a:pPr>
             <a:r>
@@ -8646,7 +8893,7 @@
           <a:bodyPr wrap="square" lIns="0" tIns="0" rIns="0" bIns="0" rtlCol="0" anchor="ctr"/>
           <a:lstStyle/>
           <a:p>
-            <a:pPr marL="0" indent="0" algn="r">
+            <a:pPr algn="r" indent="0" marL="0">
               <a:buNone/>
             </a:pPr>
             <a:r>
@@ -8680,7 +8927,6 @@
         <a:solidFill>
           <a:srgbClr val="F6F8F9"/>
         </a:solidFill>
-        <a:effectLst/>
       </p:bgPr>
     </p:bg>
     <p:spTree>
@@ -8718,11 +8964,11 @@
           <a:bodyPr wrap="square" lIns="0" tIns="0" rIns="0" bIns="0" rtlCol="0" anchor="ctr"/>
           <a:lstStyle/>
           <a:p>
-            <a:pPr marL="0" indent="0">
-              <a:buNone/>
-            </a:pPr>
-            <a:r>
-              <a:rPr lang="en-US" sz="1200" b="1" kern="0" spc="300" dirty="0">
+            <a:pPr indent="0" marL="0">
+              <a:buNone/>
+            </a:pPr>
+            <a:r>
+              <a:rPr lang="en-US" sz="1200" b="1" spc="300" kern="0" dirty="0">
                 <a:solidFill>
                   <a:srgbClr val="059669"/>
                 </a:solidFill>
@@ -8757,7 +9003,7 @@
           <a:bodyPr wrap="square" lIns="0" tIns="0" rIns="0" bIns="0" rtlCol="0" anchor="ctr"/>
           <a:lstStyle/>
           <a:p>
-            <a:pPr marL="0" indent="0">
+            <a:pPr indent="0" marL="0">
               <a:buNone/>
             </a:pPr>
             <a:r>
@@ -8801,7 +9047,7 @@
             <a:prstDash val="solid"/>
           </a:ln>
           <a:effectLst>
-            <a:outerShdw blurRad="114300" dist="38100" dir="2700000" algn="bl" rotWithShape="0">
+            <a:outerShdw sx="100000" sy="100000" kx="0" ky="0" algn="bl" rotWithShape="0" blurRad="114300" dist="38100" dir="2700000">
               <a:srgbClr val="0A1220">
                 <a:alpha val="22000"/>
               </a:srgbClr>
@@ -8830,7 +9076,7 @@
           <a:bodyPr wrap="square" lIns="0" tIns="0" rIns="0" bIns="0" rtlCol="0" anchor="ctr"/>
           <a:lstStyle/>
           <a:p>
-            <a:pPr marL="0" indent="0">
+            <a:pPr indent="0" marL="0">
               <a:buNone/>
             </a:pPr>
             <a:r>
@@ -8869,7 +9115,7 @@
           <a:bodyPr wrap="square" lIns="0" tIns="0" rIns="0" bIns="0" rtlCol="0" anchor="ctr"/>
           <a:lstStyle/>
           <a:p>
-            <a:pPr marL="0" indent="0">
+            <a:pPr indent="0" marL="0">
               <a:buNone/>
             </a:pPr>
             <a:r>
@@ -8908,7 +9154,7 @@
           <a:bodyPr wrap="square" lIns="0" tIns="0" rIns="0" bIns="0" rtlCol="0" anchor="ctr"/>
           <a:lstStyle/>
           <a:p>
-            <a:pPr marL="0" indent="0">
+            <a:pPr indent="0" marL="0">
               <a:buNone/>
             </a:pPr>
             <a:r>
@@ -8952,7 +9198,7 @@
             <a:prstDash val="solid"/>
           </a:ln>
           <a:effectLst>
-            <a:outerShdw blurRad="114300" dist="38100" dir="2700000" algn="bl" rotWithShape="0">
+            <a:outerShdw sx="100000" sy="100000" kx="0" ky="0" algn="bl" rotWithShape="0" blurRad="114300" dist="38100" dir="2700000">
               <a:srgbClr val="0A1220">
                 <a:alpha val="22000"/>
               </a:srgbClr>
@@ -8981,7 +9227,7 @@
           <a:bodyPr wrap="square" lIns="0" tIns="0" rIns="0" bIns="0" rtlCol="0" anchor="ctr"/>
           <a:lstStyle/>
           <a:p>
-            <a:pPr marL="0" indent="0">
+            <a:pPr indent="0" marL="0">
               <a:buNone/>
             </a:pPr>
             <a:r>
@@ -9020,7 +9266,7 @@
           <a:bodyPr wrap="square" lIns="0" tIns="0" rIns="0" bIns="0" rtlCol="0" anchor="ctr"/>
           <a:lstStyle/>
           <a:p>
-            <a:pPr marL="0" indent="0">
+            <a:pPr indent="0" marL="0">
               <a:buNone/>
             </a:pPr>
             <a:r>
@@ -9059,7 +9305,7 @@
           <a:bodyPr wrap="square" lIns="0" tIns="0" rIns="0" bIns="0" rtlCol="0" anchor="ctr"/>
           <a:lstStyle/>
           <a:p>
-            <a:pPr marL="0" indent="0">
+            <a:pPr indent="0" marL="0">
               <a:buNone/>
             </a:pPr>
             <a:r>
@@ -9103,7 +9349,7 @@
             <a:prstDash val="solid"/>
           </a:ln>
           <a:effectLst>
-            <a:outerShdw blurRad="114300" dist="38100" dir="2700000" algn="bl" rotWithShape="0">
+            <a:outerShdw sx="100000" sy="100000" kx="0" ky="0" algn="bl" rotWithShape="0" blurRad="114300" dist="38100" dir="2700000">
               <a:srgbClr val="0A1220">
                 <a:alpha val="22000"/>
               </a:srgbClr>
@@ -9132,7 +9378,7 @@
           <a:bodyPr wrap="square" lIns="0" tIns="0" rIns="0" bIns="0" rtlCol="0" anchor="ctr"/>
           <a:lstStyle/>
           <a:p>
-            <a:pPr marL="0" indent="0">
+            <a:pPr indent="0" marL="0">
               <a:buNone/>
             </a:pPr>
             <a:r>
@@ -9171,7 +9417,7 @@
           <a:bodyPr wrap="square" lIns="0" tIns="0" rIns="0" bIns="0" rtlCol="0" anchor="ctr"/>
           <a:lstStyle/>
           <a:p>
-            <a:pPr marL="0" indent="0">
+            <a:pPr indent="0" marL="0">
               <a:buNone/>
             </a:pPr>
             <a:r>
@@ -9210,7 +9456,7 @@
           <a:bodyPr wrap="square" lIns="0" tIns="0" rIns="0" bIns="0" rtlCol="0" anchor="ctr"/>
           <a:lstStyle/>
           <a:p>
-            <a:pPr marL="0" indent="0">
+            <a:pPr indent="0" marL="0">
               <a:buNone/>
             </a:pPr>
             <a:r>
@@ -9254,7 +9500,7 @@
             <a:prstDash val="solid"/>
           </a:ln>
           <a:effectLst>
-            <a:outerShdw blurRad="114300" dist="38100" dir="2700000" algn="bl" rotWithShape="0">
+            <a:outerShdw sx="100000" sy="100000" kx="0" ky="0" algn="bl" rotWithShape="0" blurRad="114300" dist="38100" dir="2700000">
               <a:srgbClr val="0A1220">
                 <a:alpha val="22000"/>
               </a:srgbClr>
@@ -9283,7 +9529,7 @@
           <a:bodyPr wrap="square" lIns="0" tIns="0" rIns="0" bIns="0" rtlCol="0" anchor="ctr"/>
           <a:lstStyle/>
           <a:p>
-            <a:pPr marL="0" indent="0">
+            <a:pPr indent="0" marL="0">
               <a:buNone/>
             </a:pPr>
             <a:r>
@@ -9322,7 +9568,7 @@
           <a:bodyPr wrap="square" lIns="0" tIns="0" rIns="0" bIns="0" rtlCol="0" anchor="ctr"/>
           <a:lstStyle/>
           <a:p>
-            <a:pPr marL="0" indent="0">
+            <a:pPr indent="0" marL="0">
               <a:buNone/>
             </a:pPr>
             <a:r>
@@ -9361,7 +9607,7 @@
           <a:bodyPr wrap="square" lIns="0" tIns="0" rIns="0" bIns="0" rtlCol="0" anchor="ctr"/>
           <a:lstStyle/>
           <a:p>
-            <a:pPr marL="0" indent="0">
+            <a:pPr indent="0" marL="0">
               <a:buNone/>
             </a:pPr>
             <a:r>
@@ -9405,7 +9651,7 @@
             <a:prstDash val="solid"/>
           </a:ln>
           <a:effectLst>
-            <a:outerShdw blurRad="114300" dist="38100" dir="2700000" algn="bl" rotWithShape="0">
+            <a:outerShdw sx="100000" sy="100000" kx="0" ky="0" algn="bl" rotWithShape="0" blurRad="114300" dist="38100" dir="2700000">
               <a:srgbClr val="0A1220">
                 <a:alpha val="22000"/>
               </a:srgbClr>
@@ -9434,7 +9680,7 @@
           <a:bodyPr wrap="square" lIns="0" tIns="0" rIns="0" bIns="0" rtlCol="0" anchor="ctr"/>
           <a:lstStyle/>
           <a:p>
-            <a:pPr marL="0" indent="0">
+            <a:pPr indent="0" marL="0">
               <a:buNone/>
             </a:pPr>
             <a:r>
@@ -9473,7 +9719,7 @@
           <a:bodyPr wrap="square" lIns="0" tIns="0" rIns="0" bIns="0" rtlCol="0" anchor="ctr"/>
           <a:lstStyle/>
           <a:p>
-            <a:pPr marL="0" indent="0">
+            <a:pPr indent="0" marL="0">
               <a:buNone/>
             </a:pPr>
             <a:r>
@@ -9512,7 +9758,7 @@
           <a:bodyPr wrap="square" lIns="0" tIns="0" rIns="0" bIns="0" rtlCol="0" anchor="ctr"/>
           <a:lstStyle/>
           <a:p>
-            <a:pPr marL="0" indent="0">
+            <a:pPr indent="0" marL="0">
               <a:buNone/>
             </a:pPr>
             <a:r>
@@ -9556,7 +9802,7 @@
             <a:prstDash val="solid"/>
           </a:ln>
           <a:effectLst>
-            <a:outerShdw blurRad="114300" dist="38100" dir="2700000" algn="bl" rotWithShape="0">
+            <a:outerShdw sx="100000" sy="100000" kx="0" ky="0" algn="bl" rotWithShape="0" blurRad="114300" dist="38100" dir="2700000">
               <a:srgbClr val="0A1220">
                 <a:alpha val="22000"/>
               </a:srgbClr>
@@ -9585,7 +9831,7 @@
           <a:bodyPr wrap="square" lIns="0" tIns="0" rIns="0" bIns="0" rtlCol="0" anchor="ctr"/>
           <a:lstStyle/>
           <a:p>
-            <a:pPr marL="0" indent="0">
+            <a:pPr indent="0" marL="0">
               <a:buNone/>
             </a:pPr>
             <a:r>
@@ -9624,7 +9870,7 @@
           <a:bodyPr wrap="square" lIns="0" tIns="0" rIns="0" bIns="0" rtlCol="0" anchor="ctr"/>
           <a:lstStyle/>
           <a:p>
-            <a:pPr marL="0" indent="0">
+            <a:pPr indent="0" marL="0">
               <a:buNone/>
             </a:pPr>
             <a:r>
@@ -9663,7 +9909,7 @@
           <a:bodyPr wrap="square" lIns="0" tIns="0" rIns="0" bIns="0" rtlCol="0" anchor="ctr"/>
           <a:lstStyle/>
           <a:p>
-            <a:pPr marL="0" indent="0">
+            <a:pPr indent="0" marL="0">
               <a:buNone/>
             </a:pPr>
             <a:r>
@@ -9702,7 +9948,7 @@
           <a:bodyPr wrap="square" lIns="0" tIns="0" rIns="0" bIns="0" rtlCol="0" anchor="ctr"/>
           <a:lstStyle/>
           <a:p>
-            <a:pPr marL="0" indent="0">
+            <a:pPr indent="0" marL="0">
               <a:buNone/>
             </a:pPr>
             <a:r>
@@ -9741,7 +9987,7 @@
           <a:bodyPr wrap="square" lIns="0" tIns="0" rIns="0" bIns="0" rtlCol="0" anchor="ctr"/>
           <a:lstStyle/>
           <a:p>
-            <a:pPr marL="0" indent="0" algn="r">
+            <a:pPr algn="r" indent="0" marL="0">
               <a:buNone/>
             </a:pPr>
             <a:r>
@@ -9775,7 +10021,6 @@
         <a:solidFill>
           <a:srgbClr val="F6F8F9"/>
         </a:solidFill>
-        <a:effectLst/>
       </p:bgPr>
     </p:bg>
     <p:spTree>
@@ -9813,11 +10058,11 @@
           <a:bodyPr wrap="square" lIns="0" tIns="0" rIns="0" bIns="0" rtlCol="0" anchor="ctr"/>
           <a:lstStyle/>
           <a:p>
-            <a:pPr marL="0" indent="0">
-              <a:buNone/>
-            </a:pPr>
-            <a:r>
-              <a:rPr lang="en-US" sz="1200" b="1" kern="0" spc="300" dirty="0">
+            <a:pPr indent="0" marL="0">
+              <a:buNone/>
+            </a:pPr>
+            <a:r>
+              <a:rPr lang="en-US" sz="1200" b="1" spc="300" kern="0" dirty="0">
                 <a:solidFill>
                   <a:srgbClr val="059669"/>
                 </a:solidFill>
@@ -9852,7 +10097,7 @@
           <a:bodyPr wrap="square" lIns="0" tIns="0" rIns="0" bIns="0" rtlCol="0" anchor="ctr"/>
           <a:lstStyle/>
           <a:p>
-            <a:pPr marL="0" indent="0">
+            <a:pPr indent="0" marL="0">
               <a:buNone/>
             </a:pPr>
             <a:r>
@@ -9893,7 +10138,7 @@
           <a:bodyPr wrap="square" lIns="0" tIns="0" rIns="0" bIns="0" rtlCol="0" anchor="ctr"/>
           <a:lstStyle/>
           <a:p>
-            <a:pPr marL="0" indent="0" algn="ctr">
+            <a:pPr algn="ctr" indent="0" marL="0">
               <a:buNone/>
             </a:pPr>
             <a:r>
@@ -9932,7 +10177,7 @@
           <a:bodyPr wrap="square" lIns="0" tIns="0" rIns="0" bIns="0" rtlCol="0" anchor="ctr"/>
           <a:lstStyle/>
           <a:p>
-            <a:pPr marL="0" indent="0">
+            <a:pPr indent="0" marL="0">
               <a:buNone/>
             </a:pPr>
             <a:r>
@@ -9946,6 +10191,9 @@
               </a:rPr>
               <a:t>Shop commission  —  </a:t>
             </a:r>
+            <a:pPr indent="0" marL="0">
+              <a:buNone/>
+            </a:pPr>
             <a:r>
               <a:rPr lang="en-US" sz="1300" dirty="0">
                 <a:solidFill>
@@ -10007,7 +10255,7 @@
           <a:bodyPr wrap="square" lIns="0" tIns="0" rIns="0" bIns="0" rtlCol="0" anchor="ctr"/>
           <a:lstStyle/>
           <a:p>
-            <a:pPr marL="0" indent="0" algn="ctr">
+            <a:pPr algn="ctr" indent="0" marL="0">
               <a:buNone/>
             </a:pPr>
             <a:r>
@@ -10046,7 +10294,7 @@
           <a:bodyPr wrap="square" lIns="0" tIns="0" rIns="0" bIns="0" rtlCol="0" anchor="ctr"/>
           <a:lstStyle/>
           <a:p>
-            <a:pPr marL="0" indent="0">
+            <a:pPr indent="0" marL="0">
               <a:buNone/>
             </a:pPr>
             <a:r>
@@ -10060,6 +10308,9 @@
               </a:rPr>
               <a:t>Delivery fee  —  </a:t>
             </a:r>
+            <a:pPr indent="0" marL="0">
+              <a:buNone/>
+            </a:pPr>
             <a:r>
               <a:rPr lang="en-US" sz="1300" dirty="0">
                 <a:solidFill>
@@ -10121,7 +10372,7 @@
           <a:bodyPr wrap="square" lIns="0" tIns="0" rIns="0" bIns="0" rtlCol="0" anchor="ctr"/>
           <a:lstStyle/>
           <a:p>
-            <a:pPr marL="0" indent="0" algn="ctr">
+            <a:pPr algn="ctr" indent="0" marL="0">
               <a:buNone/>
             </a:pPr>
             <a:r>
@@ -10160,7 +10411,7 @@
           <a:bodyPr wrap="square" lIns="0" tIns="0" rIns="0" bIns="0" rtlCol="0" anchor="ctr"/>
           <a:lstStyle/>
           <a:p>
-            <a:pPr marL="0" indent="0">
+            <a:pPr indent="0" marL="0">
               <a:buNone/>
             </a:pPr>
             <a:r>
@@ -10174,6 +10425,9 @@
               </a:rPr>
               <a:t>Shop subscriptions  —  </a:t>
             </a:r>
+            <a:pPr indent="0" marL="0">
+              <a:buNone/>
+            </a:pPr>
             <a:r>
               <a:rPr lang="en-US" sz="1300" dirty="0">
                 <a:solidFill>
@@ -10235,7 +10489,7 @@
           <a:bodyPr wrap="square" lIns="0" tIns="0" rIns="0" bIns="0" rtlCol="0" anchor="ctr"/>
           <a:lstStyle/>
           <a:p>
-            <a:pPr marL="0" indent="0" algn="ctr">
+            <a:pPr algn="ctr" indent="0" marL="0">
               <a:buNone/>
             </a:pPr>
             <a:r>
@@ -10274,7 +10528,7 @@
           <a:bodyPr wrap="square" lIns="0" tIns="0" rIns="0" bIns="0" rtlCol="0" anchor="ctr"/>
           <a:lstStyle/>
           <a:p>
-            <a:pPr marL="0" indent="0">
+            <a:pPr indent="0" marL="0">
               <a:buNone/>
             </a:pPr>
             <a:r>
@@ -10288,6 +10542,9 @@
               </a:rPr>
               <a:t>Sponsored listings  —  </a:t>
             </a:r>
+            <a:pPr indent="0" marL="0">
+              <a:buNone/>
+            </a:pPr>
             <a:r>
               <a:rPr lang="en-US" sz="1300" dirty="0">
                 <a:solidFill>
@@ -10349,7 +10606,7 @@
           <a:bodyPr wrap="square" lIns="0" tIns="0" rIns="0" bIns="0" rtlCol="0" anchor="ctr"/>
           <a:lstStyle/>
           <a:p>
-            <a:pPr marL="0" indent="0" algn="ctr">
+            <a:pPr algn="ctr" indent="0" marL="0">
               <a:buNone/>
             </a:pPr>
             <a:r>
@@ -10388,7 +10645,7 @@
           <a:bodyPr wrap="square" lIns="0" tIns="0" rIns="0" bIns="0" rtlCol="0" anchor="ctr"/>
           <a:lstStyle/>
           <a:p>
-            <a:pPr marL="0" indent="0">
+            <a:pPr indent="0" marL="0">
               <a:buNone/>
             </a:pPr>
             <a:r>
@@ -10402,6 +10659,9 @@
               </a:rPr>
               <a:t>White-label storefronts  —  </a:t>
             </a:r>
+            <a:pPr indent="0" marL="0">
+              <a:buNone/>
+            </a:pPr>
             <a:r>
               <a:rPr lang="en-US" sz="1300" dirty="0">
                 <a:solidFill>
@@ -10463,7 +10723,7 @@
           <a:bodyPr wrap="square" lIns="0" tIns="0" rIns="0" bIns="0" rtlCol="0" anchor="ctr"/>
           <a:lstStyle/>
           <a:p>
-            <a:pPr marL="0" indent="0" algn="ctr">
+            <a:pPr algn="ctr" indent="0" marL="0">
               <a:buNone/>
             </a:pPr>
             <a:r>
@@ -10502,7 +10762,7 @@
           <a:bodyPr wrap="square" lIns="0" tIns="0" rIns="0" bIns="0" rtlCol="0" anchor="ctr"/>
           <a:lstStyle/>
           <a:p>
-            <a:pPr marL="0" indent="0">
+            <a:pPr indent="0" marL="0">
               <a:buNone/>
             </a:pPr>
             <a:r>
@@ -10516,6 +10776,9 @@
               </a:rPr>
               <a:t>Ads &amp; insights  —  </a:t>
             </a:r>
+            <a:pPr indent="0" marL="0">
+              <a:buNone/>
+            </a:pPr>
             <a:r>
               <a:rPr lang="en-US" sz="1300" dirty="0">
                 <a:solidFill>
@@ -10574,7 +10837,7 @@
           <a:bodyPr wrap="square" lIns="0" tIns="0" rIns="0" bIns="0" rtlCol="0" anchor="ctr"/>
           <a:lstStyle/>
           <a:p>
-            <a:pPr marL="0" indent="0">
+            <a:pPr indent="0" marL="0">
               <a:buNone/>
             </a:pPr>
             <a:r>
@@ -10640,7 +10903,7 @@
           <a:bodyPr wrap="square" lIns="0" tIns="0" rIns="0" bIns="0" rtlCol="0" anchor="ctr"/>
           <a:lstStyle/>
           <a:p>
-            <a:pPr marL="0" indent="0">
+            <a:pPr indent="0" marL="0">
               <a:buNone/>
             </a:pPr>
             <a:r>
@@ -10654,6 +10917,9 @@
               </a:rPr>
               <a:t>→  </a:t>
             </a:r>
+            <a:pPr indent="0" marL="0">
+              <a:buNone/>
+            </a:pPr>
             <a:r>
               <a:rPr lang="en-US" sz="1300" b="1" dirty="0">
                 <a:solidFill>
@@ -10717,7 +10983,7 @@
           <a:bodyPr wrap="square" lIns="0" tIns="0" rIns="0" bIns="0" rtlCol="0" anchor="ctr"/>
           <a:lstStyle/>
           <a:p>
-            <a:pPr marL="0" indent="0">
+            <a:pPr indent="0" marL="0">
               <a:buNone/>
             </a:pPr>
             <a:r>
@@ -10731,6 +10997,9 @@
               </a:rPr>
               <a:t>→  </a:t>
             </a:r>
+            <a:pPr indent="0" marL="0">
+              <a:buNone/>
+            </a:pPr>
             <a:r>
               <a:rPr lang="en-US" sz="1300" b="1" dirty="0">
                 <a:solidFill>
@@ -10794,7 +11063,7 @@
           <a:bodyPr wrap="square" lIns="0" tIns="0" rIns="0" bIns="0" rtlCol="0" anchor="ctr"/>
           <a:lstStyle/>
           <a:p>
-            <a:pPr marL="0" indent="0">
+            <a:pPr indent="0" marL="0">
               <a:buNone/>
             </a:pPr>
             <a:r>
@@ -10808,6 +11077,9 @@
               </a:rPr>
               <a:t>→  </a:t>
             </a:r>
+            <a:pPr indent="0" marL="0">
+              <a:buNone/>
+            </a:pPr>
             <a:r>
               <a:rPr lang="en-US" sz="1300" b="1" dirty="0">
                 <a:solidFill>
@@ -10871,7 +11143,7 @@
           <a:bodyPr wrap="square" lIns="0" tIns="0" rIns="0" bIns="0" rtlCol="0" anchor="ctr"/>
           <a:lstStyle/>
           <a:p>
-            <a:pPr marL="0" indent="0">
+            <a:pPr indent="0" marL="0">
               <a:buNone/>
             </a:pPr>
             <a:r>
@@ -10885,6 +11157,9 @@
               </a:rPr>
               <a:t>→  </a:t>
             </a:r>
+            <a:pPr indent="0" marL="0">
+              <a:buNone/>
+            </a:pPr>
             <a:r>
               <a:rPr lang="en-US" sz="1300" b="1" dirty="0">
                 <a:solidFill>
@@ -10948,7 +11223,7 @@
           <a:bodyPr wrap="square" lIns="0" tIns="0" rIns="0" bIns="0" rtlCol="0" anchor="ctr"/>
           <a:lstStyle/>
           <a:p>
-            <a:pPr marL="0" indent="0">
+            <a:pPr indent="0" marL="0">
               <a:buNone/>
             </a:pPr>
             <a:r>
@@ -10962,6 +11237,9 @@
               </a:rPr>
               <a:t>→  </a:t>
             </a:r>
+            <a:pPr indent="0" marL="0">
+              <a:buNone/>
+            </a:pPr>
             <a:r>
               <a:rPr lang="en-US" sz="1300" b="1" dirty="0">
                 <a:solidFill>
@@ -10985,24 +11263,24 @@
         </p:nvSpPr>
         <p:spPr>
           <a:xfrm>
-            <a:off x="7726680" y="5779008"/>
-            <a:ext cx="3611880" cy="502920"/>
-          </a:xfrm>
-          <a:prstGeom prst="rect">
-            <a:avLst/>
-          </a:prstGeom>
-          <a:noFill/>
-          <a:ln/>
-        </p:spPr>
-        <p:txBody>
-          <a:bodyPr wrap="square" lIns="0" tIns="0" rIns="0" bIns="0" rtlCol="0" anchor="ctr"/>
-          <a:lstStyle/>
-          <a:p>
-            <a:pPr marL="0" indent="0">
-              <a:buNone/>
-            </a:pPr>
-            <a:r>
-              <a:rPr lang="en-US" sz="1050" i="1" dirty="0">
+            <a:off x="7726680" y="5669280"/>
+            <a:ext cx="3566160" cy="384048"/>
+          </a:xfrm>
+          <a:prstGeom prst="rect">
+            <a:avLst/>
+          </a:prstGeom>
+          <a:noFill/>
+          <a:ln/>
+        </p:spPr>
+        <p:txBody>
+          <a:bodyPr wrap="square" lIns="0" tIns="0" rIns="0" bIns="0" rtlCol="0" anchor="ctr"/>
+          <a:lstStyle/>
+          <a:p>
+            <a:pPr indent="0" marL="0">
+              <a:buNone/>
+            </a:pPr>
+            <a:r>
+              <a:rPr lang="en-US" sz="1000" i="1" dirty="0">
                 <a:solidFill>
                   <a:srgbClr val="9FB0C0"/>
                 </a:solidFill>
@@ -11010,9 +11288,9 @@
                 <a:ea typeface="Segoe UI" pitchFamily="34" charset="-122"/>
                 <a:cs typeface="Segoe UI" pitchFamily="34" charset="-120"/>
               </a:rPr>
-              <a:t>…which onboards more shops. NearCoins, streaks and referrals keep the customer side spinning.</a:t>
-            </a:r>
-            <a:endParaRPr lang="en-US" sz="1050" dirty="0"/>
+              <a:t>…which onboards more shops. NearCoins &amp; referrals keep demand spinning.</a:t>
+            </a:r>
+            <a:endParaRPr lang="en-US" sz="1000" dirty="0"/>
           </a:p>
         </p:txBody>
       </p:sp>
@@ -11037,7 +11315,7 @@
           <a:bodyPr wrap="square" lIns="0" tIns="0" rIns="0" bIns="0" rtlCol="0" anchor="ctr"/>
           <a:lstStyle/>
           <a:p>
-            <a:pPr marL="0" indent="0" algn="r">
+            <a:pPr algn="r" indent="0" marL="0">
               <a:buNone/>
             </a:pPr>
             <a:r>
@@ -11356,299 +11634,4 @@
     </a:ext>
   </a:extLst>
 </a:theme>
-</file>
-
-<file path=ppt/theme/theme2.xml><?xml version="1.0" encoding="utf-8"?>
-<a:theme xmlns:a="http://schemas.openxmlformats.org/drawingml/2006/main" name="Office Theme">
-  <a:themeElements>
-    <a:clrScheme name="Office">
-      <a:dk1>
-        <a:sysClr val="windowText" lastClr="000000"/>
-      </a:dk1>
-      <a:lt1>
-        <a:sysClr val="window" lastClr="FFFFFF"/>
-      </a:lt1>
-      <a:dk2>
-        <a:srgbClr val="44546A"/>
-      </a:dk2>
-      <a:lt2>
-        <a:srgbClr val="E7E6E6"/>
-      </a:lt2>
-      <a:accent1>
-        <a:srgbClr val="4472C4"/>
-      </a:accent1>
-      <a:accent2>
-        <a:srgbClr val="ED7D31"/>
-      </a:accent2>
-      <a:accent3>
-        <a:srgbClr val="A5A5A5"/>
-      </a:accent3>
-      <a:accent4>
-        <a:srgbClr val="FFC000"/>
-      </a:accent4>
-      <a:accent5>
-        <a:srgbClr val="5B9BD5"/>
-      </a:accent5>
-      <a:accent6>
-        <a:srgbClr val="70AD47"/>
-      </a:accent6>
-      <a:hlink>
-        <a:srgbClr val="0563C1"/>
-      </a:hlink>
-      <a:folHlink>
-        <a:srgbClr val="954F72"/>
-      </a:folHlink>
-    </a:clrScheme>
-    <a:fontScheme name="Office">
-      <a:majorFont>
-        <a:latin typeface="Calibri Light" panose="020F0302020204030204"/>
-        <a:ea typeface=""/>
-        <a:cs typeface=""/>
-        <a:font script="Jpan" typeface="游ゴシック Light"/>
-        <a:font script="Hang" typeface="맑은 고딕"/>
-        <a:font script="Hans" typeface="等线 Light"/>
-        <a:font script="Hant" typeface="新細明體"/>
-        <a:font script="Arab" typeface="Times New Roman"/>
-        <a:font script="Hebr" typeface="Times New Roman"/>
-        <a:font script="Thai" typeface="Angsana New"/>
-        <a:font script="Ethi" typeface="Nyala"/>
-        <a:font script="Beng" typeface="Vrinda"/>
-        <a:font script="Gujr" typeface="Shruti"/>
-        <a:font script="Khmr" typeface="MoolBoran"/>
-        <a:font script="Knda" typeface="Tunga"/>
-        <a:font script="Guru" typeface="Raavi"/>
-        <a:font script="Cans" typeface="Euphemia"/>
-        <a:font script="Cher" typeface="Plantagenet Cherokee"/>
-        <a:font script="Yiii" typeface="Microsoft Yi Baiti"/>
-        <a:font script="Tibt" typeface="Microsoft Himalaya"/>
-        <a:font script="Thaa" typeface="MV Boli"/>
-        <a:font script="Deva" typeface="Mangal"/>
-        <a:font script="Telu" typeface="Gautami"/>
-        <a:font script="Taml" typeface="Latha"/>
-        <a:font script="Syrc" typeface="Estrangelo Edessa"/>
-        <a:font script="Orya" typeface="Kalinga"/>
-        <a:font script="Mlym" typeface="Kartika"/>
-        <a:font script="Laoo" typeface="DokChampa"/>
-        <a:font script="Sinh" typeface="Iskoola Pota"/>
-        <a:font script="Mong" typeface="Mongolian Baiti"/>
-        <a:font script="Viet" typeface="Times New Roman"/>
-        <a:font script="Uigh" typeface="Microsoft Uighur"/>
-        <a:font script="Geor" typeface="Sylfaen"/>
-        <a:font script="Armn" typeface="Arial"/>
-        <a:font script="Bugi" typeface="Leelawadee UI"/>
-        <a:font script="Bopo" typeface="Microsoft JhengHei"/>
-        <a:font script="Java" typeface="Javanese Text"/>
-        <a:font script="Lisu" typeface="Segoe UI"/>
-        <a:font script="Mymr" typeface="Myanmar Text"/>
-        <a:font script="Nkoo" typeface="Ebrima"/>
-        <a:font script="Olck" typeface="Nirmala UI"/>
-        <a:font script="Osma" typeface="Ebrima"/>
-        <a:font script="Phag" typeface="Phagspa"/>
-        <a:font script="Syrn" typeface="Estrangelo Edessa"/>
-        <a:font script="Syrj" typeface="Estrangelo Edessa"/>
-        <a:font script="Syre" typeface="Estrangelo Edessa"/>
-        <a:font script="Sora" typeface="Nirmala UI"/>
-        <a:font script="Tale" typeface="Microsoft Tai Le"/>
-        <a:font script="Talu" typeface="Microsoft New Tai Lue"/>
-        <a:font script="Tfng" typeface="Ebrima"/>
-      </a:majorFont>
-      <a:minorFont>
-        <a:latin typeface="Calibri" panose="020F0502020204030204"/>
-        <a:ea typeface=""/>
-        <a:cs typeface=""/>
-        <a:font script="Jpan" typeface="游ゴシック"/>
-        <a:font script="Hang" typeface="맑은 고딕"/>
-        <a:font script="Hans" typeface="等线"/>
-        <a:font script="Hant" typeface="新細明體"/>
-        <a:font script="Arab" typeface="Arial"/>
-        <a:font script="Hebr" typeface="Arial"/>
-        <a:font script="Thai" typeface="Cordia New"/>
-        <a:font script="Ethi" typeface="Nyala"/>
-        <a:font script="Beng" typeface="Vrinda"/>
-        <a:font script="Gujr" typeface="Shruti"/>
-        <a:font script="Khmr" typeface="DaunPenh"/>
-        <a:font script="Knda" typeface="Tunga"/>
-        <a:font script="Guru" typeface="Raavi"/>
-        <a:font script="Cans" typeface="Euphemia"/>
-        <a:font script="Cher" typeface="Plantagenet Cherokee"/>
-        <a:font script="Yiii" typeface="Microsoft Yi Baiti"/>
-        <a:font script="Tibt" typeface="Microsoft Himalaya"/>
-        <a:font script="Thaa" typeface="MV Boli"/>
-        <a:font script="Deva" typeface="Mangal"/>
-        <a:font script="Telu" typeface="Gautami"/>
-        <a:font script="Taml" typeface="Latha"/>
-        <a:font script="Syrc" typeface="Estrangelo Edessa"/>
-        <a:font script="Orya" typeface="Kalinga"/>
-        <a:font script="Mlym" typeface="Kartika"/>
-        <a:font script="Laoo" typeface="DokChampa"/>
-        <a:font script="Sinh" typeface="Iskoola Pota"/>
-        <a:font script="Mong" typeface="Mongolian Baiti"/>
-        <a:font script="Viet" typeface="Arial"/>
-        <a:font script="Uigh" typeface="Microsoft Uighur"/>
-        <a:font script="Geor" typeface="Sylfaen"/>
-        <a:font script="Armn" typeface="Arial"/>
-        <a:font script="Bugi" typeface="Leelawadee UI"/>
-        <a:font script="Bopo" typeface="Microsoft JhengHei"/>
-        <a:font script="Java" typeface="Javanese Text"/>
-        <a:font script="Lisu" typeface="Segoe UI"/>
-        <a:font script="Mymr" typeface="Myanmar Text"/>
-        <a:font script="Nkoo" typeface="Ebrima"/>
-        <a:font script="Olck" typeface="Nirmala UI"/>
-        <a:font script="Osma" typeface="Ebrima"/>
-        <a:font script="Phag" typeface="Phagspa"/>
-        <a:font script="Syrn" typeface="Estrangelo Edessa"/>
-        <a:font script="Syrj" typeface="Estrangelo Edessa"/>
-        <a:font script="Syre" typeface="Estrangelo Edessa"/>
-        <a:font script="Sora" typeface="Nirmala UI"/>
-        <a:font script="Tale" typeface="Microsoft Tai Le"/>
-        <a:font script="Talu" typeface="Microsoft New Tai Lue"/>
-        <a:font script="Tfng" typeface="Ebrima"/>
-      </a:minorFont>
-    </a:fontScheme>
-    <a:fmtScheme name="Office">
-      <a:fillStyleLst>
-        <a:solidFill>
-          <a:schemeClr val="phClr"/>
-        </a:solidFill>
-        <a:gradFill rotWithShape="1">
-          <a:gsLst>
-            <a:gs pos="0">
-              <a:schemeClr val="phClr">
-                <a:lumMod val="110000"/>
-                <a:satMod val="105000"/>
-                <a:tint val="67000"/>
-              </a:schemeClr>
-            </a:gs>
-            <a:gs pos="50000">
-              <a:schemeClr val="phClr">
-                <a:lumMod val="105000"/>
-                <a:satMod val="103000"/>
-                <a:tint val="73000"/>
-              </a:schemeClr>
-            </a:gs>
-            <a:gs pos="100000">
-              <a:schemeClr val="phClr">
-                <a:lumMod val="105000"/>
-                <a:satMod val="109000"/>
-                <a:tint val="81000"/>
-              </a:schemeClr>
-            </a:gs>
-          </a:gsLst>
-          <a:lin ang="5400000" scaled="0"/>
-        </a:gradFill>
-        <a:gradFill rotWithShape="1">
-          <a:gsLst>
-            <a:gs pos="0">
-              <a:schemeClr val="phClr">
-                <a:satMod val="103000"/>
-                <a:lumMod val="102000"/>
-                <a:tint val="94000"/>
-              </a:schemeClr>
-            </a:gs>
-            <a:gs pos="50000">
-              <a:schemeClr val="phClr">
-                <a:satMod val="110000"/>
-                <a:lumMod val="100000"/>
-                <a:shade val="100000"/>
-              </a:schemeClr>
-            </a:gs>
-            <a:gs pos="100000">
-              <a:schemeClr val="phClr">
-                <a:lumMod val="99000"/>
-                <a:satMod val="120000"/>
-                <a:shade val="78000"/>
-              </a:schemeClr>
-            </a:gs>
-          </a:gsLst>
-          <a:lin ang="5400000" scaled="0"/>
-        </a:gradFill>
-      </a:fillStyleLst>
-      <a:lnStyleLst>
-        <a:ln w="6350" cap="flat" cmpd="sng" algn="ctr">
-          <a:solidFill>
-            <a:schemeClr val="phClr"/>
-          </a:solidFill>
-          <a:prstDash val="solid"/>
-          <a:miter lim="800000"/>
-        </a:ln>
-        <a:ln w="12700" cap="flat" cmpd="sng" algn="ctr">
-          <a:solidFill>
-            <a:schemeClr val="phClr"/>
-          </a:solidFill>
-          <a:prstDash val="solid"/>
-          <a:miter lim="800000"/>
-        </a:ln>
-        <a:ln w="19050" cap="flat" cmpd="sng" algn="ctr">
-          <a:solidFill>
-            <a:schemeClr val="phClr"/>
-          </a:solidFill>
-          <a:prstDash val="solid"/>
-          <a:miter lim="800000"/>
-        </a:ln>
-      </a:lnStyleLst>
-      <a:effectStyleLst>
-        <a:effectStyle>
-          <a:effectLst/>
-        </a:effectStyle>
-        <a:effectStyle>
-          <a:effectLst/>
-        </a:effectStyle>
-        <a:effectStyle>
-          <a:effectLst>
-            <a:outerShdw blurRad="57150" dist="19050" dir="5400000" algn="ctr" rotWithShape="0">
-              <a:srgbClr val="000000">
-                <a:alpha val="63000"/>
-              </a:srgbClr>
-            </a:outerShdw>
-          </a:effectLst>
-        </a:effectStyle>
-      </a:effectStyleLst>
-      <a:bgFillStyleLst>
-        <a:solidFill>
-          <a:schemeClr val="phClr"/>
-        </a:solidFill>
-        <a:solidFill>
-          <a:schemeClr val="phClr">
-            <a:tint val="95000"/>
-            <a:satMod val="170000"/>
-          </a:schemeClr>
-        </a:solidFill>
-        <a:gradFill rotWithShape="1">
-          <a:gsLst>
-            <a:gs pos="0">
-              <a:schemeClr val="phClr">
-                <a:tint val="93000"/>
-                <a:satMod val="150000"/>
-                <a:shade val="98000"/>
-                <a:lumMod val="102000"/>
-              </a:schemeClr>
-            </a:gs>
-            <a:gs pos="50000">
-              <a:schemeClr val="phClr">
-                <a:tint val="98000"/>
-                <a:satMod val="130000"/>
-                <a:shade val="90000"/>
-                <a:lumMod val="103000"/>
-              </a:schemeClr>
-            </a:gs>
-            <a:gs pos="100000">
-              <a:schemeClr val="phClr">
-                <a:shade val="63000"/>
-                <a:satMod val="120000"/>
-              </a:schemeClr>
-            </a:gs>
-          </a:gsLst>
-          <a:lin ang="5400000" scaled="0"/>
-        </a:gradFill>
-      </a:bgFillStyleLst>
-    </a:fmtScheme>
-  </a:themeElements>
-  <a:objectDefaults/>
-  <a:extraClrSchemeLst/>
-  <a:extLst>
-    <a:ext uri="{05A4C25C-085E-4340-85A3-A5531E510DB2}">
-      <thm15:themeFamily xmlns:thm15="http://schemas.microsoft.com/office/thememl/2012/main" name="Office Theme" id="{62F939B6-93AF-4DB8-9C6B-D6C7DFDC589F}" vid="{4A3C46E8-61CC-4603-A589-7422A47A8E4A}"/>
-    </a:ext>
-  </a:extLst>
-</a:theme>
 </file>
</xml_diff>